<commit_message>
Fix duplicate cluster slide metrics
</commit_message>
<xml_diff>
--- a/version11_delivery/pitch_deck/dataleague_v11_final_pitch_deck.pptx
+++ b/version11_delivery/pitch_deck/dataleague_v11_final_pitch_deck.pptx
@@ -14491,7 +14491,7 @@
         <p:spPr>
           <a:xfrm>
             <a:off x="6565392" y="2029967"/>
-            <a:ext cx="1508760" cy="164592"/>
+            <a:ext cx="2029968" cy="164592"/>
           </a:xfrm>
           <a:prstGeom prst="rect">
             <a:avLst/>
@@ -14506,13 +14506,13 @@
           <a:p>
             <a:pPr algn="l"/>
             <a:r>
-              <a:rPr sz="800" b="1">
+              <a:rPr sz="700" b="1">
                 <a:solidFill>
                   <a:srgbClr val="E6483D"/>
                 </a:solidFill>
                 <a:latin typeface="Aptos"/>
               </a:rPr>
-              <a:t>883 tekrar | skor 0.000</a:t>
+              <a:t>883 tekrar | ort 0.997 | max 0.997</a:t>
             </a:r>
           </a:p>
         </p:txBody>
@@ -14525,8 +14525,8 @@
         </p:nvSpPr>
         <p:spPr>
           <a:xfrm>
-            <a:off x="8092440" y="2020824"/>
-            <a:ext cx="2743200" cy="256032"/>
+            <a:off x="8668512" y="2020824"/>
+            <a:ext cx="2130552" cy="256032"/>
           </a:xfrm>
           <a:prstGeom prst="rect">
             <a:avLst/>
@@ -14547,7 +14547,7 @@
                 </a:solidFill>
                 <a:latin typeface="Aptos"/>
               </a:rPr>
-              <a:t/>
+              <a:t>  高端局 有门槛 介意勿扰 点头像进主页去电报看资料！</a:t>
             </a:r>
           </a:p>
         </p:txBody>
@@ -14606,7 +14606,7 @@
         <p:spPr>
           <a:xfrm>
             <a:off x="6565392" y="2779775"/>
-            <a:ext cx="1508760" cy="164592"/>
+            <a:ext cx="2029968" cy="164592"/>
           </a:xfrm>
           <a:prstGeom prst="rect">
             <a:avLst/>
@@ -14621,13 +14621,13 @@
           <a:p>
             <a:pPr algn="l"/>
             <a:r>
-              <a:rPr sz="800" b="1">
+              <a:rPr sz="700" b="1">
                 <a:solidFill>
                   <a:srgbClr val="E6483D"/>
                 </a:solidFill>
                 <a:latin typeface="Aptos"/>
               </a:rPr>
-              <a:t>469 tekrar | skor 0.000</a:t>
+              <a:t>469 tekrar | ort 0.997 | max 0.997</a:t>
             </a:r>
           </a:p>
         </p:txBody>
@@ -14640,8 +14640,8 @@
         </p:nvSpPr>
         <p:spPr>
           <a:xfrm>
-            <a:off x="8092440" y="2770632"/>
-            <a:ext cx="2743200" cy="256032"/>
+            <a:off x="8668512" y="2770632"/>
+            <a:ext cx="2130552" cy="256032"/>
           </a:xfrm>
           <a:prstGeom prst="rect">
             <a:avLst/>
@@ -14662,7 +14662,7 @@
                 </a:solidFill>
                 <a:latin typeface="Aptos"/>
               </a:rPr>
-              <a:t/>
+              <a:t>The wait is almost over — $SOON is coming in hot, courtesy of  @tonstationgames . Season 2 around the corner; let’s cr</a:t>
             </a:r>
           </a:p>
         </p:txBody>
@@ -14721,7 +14721,7 @@
         <p:spPr>
           <a:xfrm>
             <a:off x="6565392" y="3529583"/>
-            <a:ext cx="1508760" cy="164592"/>
+            <a:ext cx="2029968" cy="164592"/>
           </a:xfrm>
           <a:prstGeom prst="rect">
             <a:avLst/>
@@ -14736,13 +14736,13 @@
           <a:p>
             <a:pPr algn="l"/>
             <a:r>
-              <a:rPr sz="800" b="1">
+              <a:rPr sz="700" b="1">
                 <a:solidFill>
                   <a:srgbClr val="E6483D"/>
                 </a:solidFill>
                 <a:latin typeface="Aptos"/>
               </a:rPr>
-              <a:t>392 tekrar | skor 0.000</a:t>
+              <a:t>392 tekrar | ort 0.997 | max 0.997</a:t>
             </a:r>
           </a:p>
         </p:txBody>
@@ -14755,8 +14755,8 @@
         </p:nvSpPr>
         <p:spPr>
           <a:xfrm>
-            <a:off x="8092440" y="3520439"/>
-            <a:ext cx="2743200" cy="256032"/>
+            <a:off x="8668512" y="3520439"/>
+            <a:ext cx="2130552" cy="256032"/>
           </a:xfrm>
           <a:prstGeom prst="rect">
             <a:avLst/>
@@ -14777,7 +14777,7 @@
                 </a:solidFill>
                 <a:latin typeface="Aptos"/>
               </a:rPr>
-              <a:t/>
+              <a:t>The BabyDoge community is growing rapidly with passion, utility, and innovation! We'd love to see BabyDoge  @babydogec</a:t>
             </a:r>
           </a:p>
         </p:txBody>
@@ -14836,7 +14836,7 @@
         <p:spPr>
           <a:xfrm>
             <a:off x="6565392" y="4279392"/>
-            <a:ext cx="1508760" cy="164592"/>
+            <a:ext cx="2029968" cy="164592"/>
           </a:xfrm>
           <a:prstGeom prst="rect">
             <a:avLst/>
@@ -14851,13 +14851,13 @@
           <a:p>
             <a:pPr algn="l"/>
             <a:r>
-              <a:rPr sz="800" b="1">
+              <a:rPr sz="700" b="1">
                 <a:solidFill>
                   <a:srgbClr val="E6483D"/>
                 </a:solidFill>
                 <a:latin typeface="Aptos"/>
               </a:rPr>
-              <a:t>332 tekrar | skor 0.000</a:t>
+              <a:t>332 tekrar | ort 0.991 | max 0.991</a:t>
             </a:r>
           </a:p>
         </p:txBody>
@@ -14870,8 +14870,8 @@
         </p:nvSpPr>
         <p:spPr>
           <a:xfrm>
-            <a:off x="8092440" y="4270248"/>
-            <a:ext cx="2743200" cy="256032"/>
+            <a:off x="8668512" y="4270248"/>
+            <a:ext cx="2130552" cy="256032"/>
           </a:xfrm>
           <a:prstGeom prst="rect">
             <a:avLst/>
@@ -14892,7 +14892,7 @@
                 </a:solidFill>
                 <a:latin typeface="Aptos"/>
               </a:rPr>
-              <a:t/>
+              <a:t>I'm buzzing with excitement for the $SOON token listing from @tonstationgames! These guys are the hottest gaming platf</a:t>
             </a:r>
           </a:p>
         </p:txBody>

</xml_diff>

<commit_message>
Add batch sample and improve deck text fitting
</commit_message>
<xml_diff>
--- a/version11_delivery/pitch_deck/dataleague_v11_final_pitch_deck.pptx
+++ b/version11_delivery/pitch_deck/dataleague_v11_final_pitch_deck.pptx
@@ -3847,8 +3847,8 @@
           <a:noFill/>
         </p:spPr>
         <p:txBody>
-          <a:bodyPr wrap="none" lIns="18288" rIns="18288" tIns="18288" bIns="18288" anchor="t">
-            <a:spAutoFit/>
+          <a:bodyPr wrap="square" lIns="18288" rIns="18288" tIns="18288" bIns="18288" anchor="t">
+            <a:normAutofit/>
           </a:bodyPr>
           <a:lstStyle/>
           <a:p>
@@ -3882,8 +3882,8 @@
           <a:noFill/>
         </p:spPr>
         <p:txBody>
-          <a:bodyPr wrap="none" lIns="18288" rIns="18288" tIns="18288" bIns="18288" anchor="t">
-            <a:spAutoFit/>
+          <a:bodyPr wrap="square" lIns="18288" rIns="18288" tIns="18288" bIns="18288" anchor="t">
+            <a:normAutofit/>
           </a:bodyPr>
           <a:lstStyle/>
           <a:p>
@@ -3918,8 +3918,8 @@
           <a:noFill/>
         </p:spPr>
         <p:txBody>
-          <a:bodyPr wrap="none" lIns="18288" rIns="18288" tIns="18288" bIns="18288" anchor="t">
-            <a:spAutoFit/>
+          <a:bodyPr wrap="square" lIns="18288" rIns="18288" tIns="18288" bIns="18288" anchor="t">
+            <a:normAutofit/>
           </a:bodyPr>
           <a:lstStyle/>
           <a:p>
@@ -3953,8 +3953,8 @@
           <a:noFill/>
         </p:spPr>
         <p:txBody>
-          <a:bodyPr wrap="none" lIns="18288" rIns="18288" tIns="18288" bIns="18288" anchor="t">
-            <a:spAutoFit/>
+          <a:bodyPr wrap="square" lIns="18288" rIns="18288" tIns="18288" bIns="18288" anchor="t">
+            <a:normAutofit/>
           </a:bodyPr>
           <a:lstStyle/>
           <a:p>
@@ -3988,8 +3988,8 @@
           <a:noFill/>
         </p:spPr>
         <p:txBody>
-          <a:bodyPr wrap="none" lIns="18288" rIns="18288" tIns="18288" bIns="18288" anchor="t">
-            <a:spAutoFit/>
+          <a:bodyPr wrap="square" lIns="18288" rIns="18288" tIns="18288" bIns="18288" anchor="t">
+            <a:normAutofit/>
           </a:bodyPr>
           <a:lstStyle/>
           <a:p>
@@ -4023,8 +4023,8 @@
           <a:noFill/>
         </p:spPr>
         <p:txBody>
-          <a:bodyPr wrap="none" lIns="18288" rIns="18288" tIns="18288" bIns="18288" anchor="t">
-            <a:spAutoFit/>
+          <a:bodyPr wrap="square" lIns="18288" rIns="18288" tIns="18288" bIns="18288" anchor="t">
+            <a:normAutofit/>
           </a:bodyPr>
           <a:lstStyle/>
           <a:p>
@@ -4058,8 +4058,8 @@
           <a:noFill/>
         </p:spPr>
         <p:txBody>
-          <a:bodyPr wrap="none" lIns="18288" rIns="18288" tIns="18288" bIns="18288" anchor="t">
-            <a:spAutoFit/>
+          <a:bodyPr wrap="square" lIns="18288" rIns="18288" tIns="18288" bIns="18288" anchor="t">
+            <a:normAutofit/>
           </a:bodyPr>
           <a:lstStyle/>
           <a:p>
@@ -4093,8 +4093,8 @@
           <a:noFill/>
         </p:spPr>
         <p:txBody>
-          <a:bodyPr wrap="none" lIns="18288" rIns="18288" tIns="18288" bIns="18288" anchor="t">
-            <a:spAutoFit/>
+          <a:bodyPr wrap="square" lIns="18288" rIns="18288" tIns="18288" bIns="18288" anchor="t">
+            <a:normAutofit/>
           </a:bodyPr>
           <a:lstStyle/>
           <a:p>
@@ -4128,8 +4128,8 @@
           <a:noFill/>
         </p:spPr>
         <p:txBody>
-          <a:bodyPr wrap="none" lIns="18288" rIns="18288" tIns="18288" bIns="18288" anchor="t">
-            <a:spAutoFit/>
+          <a:bodyPr wrap="square" lIns="18288" rIns="18288" tIns="18288" bIns="18288" anchor="t">
+            <a:normAutofit/>
           </a:bodyPr>
           <a:lstStyle/>
           <a:p>
@@ -4206,8 +4206,8 @@
           <a:noFill/>
         </p:spPr>
         <p:txBody>
-          <a:bodyPr wrap="none" lIns="18288" rIns="18288" tIns="18288" bIns="18288" anchor="t">
-            <a:spAutoFit/>
+          <a:bodyPr wrap="square" lIns="18288" rIns="18288" tIns="18288" bIns="18288" anchor="t">
+            <a:normAutofit/>
           </a:bodyPr>
           <a:lstStyle/>
           <a:p>
@@ -4284,8 +4284,8 @@
           <a:noFill/>
         </p:spPr>
         <p:txBody>
-          <a:bodyPr wrap="none" lIns="18288" rIns="18288" tIns="18288" bIns="18288" anchor="t">
-            <a:spAutoFit/>
+          <a:bodyPr wrap="square" lIns="18288" rIns="18288" tIns="18288" bIns="18288" anchor="t">
+            <a:normAutofit/>
           </a:bodyPr>
           <a:lstStyle/>
           <a:p>
@@ -4362,8 +4362,8 @@
           <a:noFill/>
         </p:spPr>
         <p:txBody>
-          <a:bodyPr wrap="none" lIns="18288" rIns="18288" tIns="18288" bIns="18288" anchor="t">
-            <a:spAutoFit/>
+          <a:bodyPr wrap="square" lIns="18288" rIns="18288" tIns="18288" bIns="18288" anchor="t">
+            <a:normAutofit/>
           </a:bodyPr>
           <a:lstStyle/>
           <a:p>
@@ -4440,8 +4440,8 @@
           <a:noFill/>
         </p:spPr>
         <p:txBody>
-          <a:bodyPr wrap="none" lIns="18288" rIns="18288" tIns="18288" bIns="18288" anchor="t">
-            <a:spAutoFit/>
+          <a:bodyPr wrap="square" lIns="18288" rIns="18288" tIns="18288" bIns="18288" anchor="t">
+            <a:normAutofit/>
           </a:bodyPr>
           <a:lstStyle/>
           <a:p>
@@ -4475,8 +4475,8 @@
           <a:noFill/>
         </p:spPr>
         <p:txBody>
-          <a:bodyPr wrap="none" lIns="18288" rIns="18288" tIns="18288" bIns="18288" anchor="t">
-            <a:spAutoFit/>
+          <a:bodyPr wrap="square" lIns="18288" rIns="18288" tIns="18288" bIns="18288" anchor="t">
+            <a:normAutofit/>
           </a:bodyPr>
           <a:lstStyle/>
           <a:p>
@@ -4510,8 +4510,8 @@
           <a:noFill/>
         </p:spPr>
         <p:txBody>
-          <a:bodyPr wrap="none" lIns="18288" rIns="18288" tIns="18288" bIns="18288" anchor="t">
-            <a:spAutoFit/>
+          <a:bodyPr wrap="square" lIns="18288" rIns="18288" tIns="18288" bIns="18288" anchor="t">
+            <a:normAutofit/>
           </a:bodyPr>
           <a:lstStyle/>
           <a:p>
@@ -4571,8 +4571,8 @@
           <a:noFill/>
         </p:spPr>
         <p:txBody>
-          <a:bodyPr wrap="none" lIns="18288" rIns="18288" tIns="18288" bIns="18288" anchor="t">
-            <a:spAutoFit/>
+          <a:bodyPr wrap="square" lIns="18288" rIns="18288" tIns="18288" bIns="18288" anchor="t">
+            <a:normAutofit/>
           </a:bodyPr>
           <a:lstStyle/>
           <a:p>
@@ -4606,8 +4606,8 @@
           <a:noFill/>
         </p:spPr>
         <p:txBody>
-          <a:bodyPr wrap="none" lIns="18288" rIns="18288" tIns="18288" bIns="18288" anchor="t">
-            <a:spAutoFit/>
+          <a:bodyPr wrap="square" lIns="18288" rIns="18288" tIns="18288" bIns="18288" anchor="t">
+            <a:normAutofit/>
           </a:bodyPr>
           <a:lstStyle/>
           <a:p>
@@ -4684,8 +4684,8 @@
           <a:noFill/>
         </p:spPr>
         <p:txBody>
-          <a:bodyPr wrap="none" lIns="18288" rIns="18288" tIns="18288" bIns="18288" anchor="t">
-            <a:spAutoFit/>
+          <a:bodyPr wrap="square" lIns="18288" rIns="18288" tIns="18288" bIns="18288" anchor="t">
+            <a:normAutofit/>
           </a:bodyPr>
           <a:lstStyle/>
           <a:p>
@@ -4719,8 +4719,8 @@
           <a:noFill/>
         </p:spPr>
         <p:txBody>
-          <a:bodyPr wrap="none" lIns="18288" rIns="18288" tIns="18288" bIns="18288" anchor="t">
-            <a:spAutoFit/>
+          <a:bodyPr wrap="square" lIns="18288" rIns="18288" tIns="18288" bIns="18288" anchor="t">
+            <a:normAutofit/>
           </a:bodyPr>
           <a:lstStyle/>
           <a:p>
@@ -4849,8 +4849,8 @@
           <a:noFill/>
         </p:spPr>
         <p:txBody>
-          <a:bodyPr wrap="none" lIns="18288" rIns="18288" tIns="18288" bIns="18288" anchor="t">
-            <a:spAutoFit/>
+          <a:bodyPr wrap="square" lIns="18288" rIns="18288" tIns="18288" bIns="18288" anchor="t">
+            <a:normAutofit/>
           </a:bodyPr>
           <a:lstStyle/>
           <a:p>
@@ -4884,8 +4884,8 @@
           <a:noFill/>
         </p:spPr>
         <p:txBody>
-          <a:bodyPr wrap="none" lIns="18288" rIns="18288" tIns="18288" bIns="18288" anchor="t">
-            <a:spAutoFit/>
+          <a:bodyPr wrap="square" lIns="18288" rIns="18288" tIns="18288" bIns="18288" anchor="t">
+            <a:normAutofit/>
           </a:bodyPr>
           <a:lstStyle/>
           <a:p>
@@ -5014,8 +5014,8 @@
           <a:noFill/>
         </p:spPr>
         <p:txBody>
-          <a:bodyPr wrap="none" lIns="18288" rIns="18288" tIns="18288" bIns="18288" anchor="t">
-            <a:spAutoFit/>
+          <a:bodyPr wrap="square" lIns="18288" rIns="18288" tIns="18288" bIns="18288" anchor="t">
+            <a:normAutofit/>
           </a:bodyPr>
           <a:lstStyle/>
           <a:p>
@@ -5049,8 +5049,8 @@
           <a:noFill/>
         </p:spPr>
         <p:txBody>
-          <a:bodyPr wrap="none" lIns="18288" rIns="18288" tIns="18288" bIns="18288" anchor="t">
-            <a:spAutoFit/>
+          <a:bodyPr wrap="square" lIns="18288" rIns="18288" tIns="18288" bIns="18288" anchor="t">
+            <a:normAutofit/>
           </a:bodyPr>
           <a:lstStyle/>
           <a:p>
@@ -5179,8 +5179,8 @@
           <a:noFill/>
         </p:spPr>
         <p:txBody>
-          <a:bodyPr wrap="none" lIns="18288" rIns="18288" tIns="18288" bIns="18288" anchor="t">
-            <a:spAutoFit/>
+          <a:bodyPr wrap="square" lIns="18288" rIns="18288" tIns="18288" bIns="18288" anchor="t">
+            <a:normAutofit/>
           </a:bodyPr>
           <a:lstStyle/>
           <a:p>
@@ -5214,8 +5214,8 @@
           <a:noFill/>
         </p:spPr>
         <p:txBody>
-          <a:bodyPr wrap="none" lIns="18288" rIns="18288" tIns="18288" bIns="18288" anchor="t">
-            <a:spAutoFit/>
+          <a:bodyPr wrap="square" lIns="18288" rIns="18288" tIns="18288" bIns="18288" anchor="t">
+            <a:normAutofit/>
           </a:bodyPr>
           <a:lstStyle/>
           <a:p>
@@ -5344,8 +5344,8 @@
           <a:noFill/>
         </p:spPr>
         <p:txBody>
-          <a:bodyPr wrap="none" lIns="18288" rIns="18288" tIns="18288" bIns="18288" anchor="t">
-            <a:spAutoFit/>
+          <a:bodyPr wrap="square" lIns="18288" rIns="18288" tIns="18288" bIns="18288" anchor="t">
+            <a:normAutofit/>
           </a:bodyPr>
           <a:lstStyle/>
           <a:p>
@@ -5379,8 +5379,8 @@
           <a:noFill/>
         </p:spPr>
         <p:txBody>
-          <a:bodyPr wrap="none" lIns="18288" rIns="18288" tIns="18288" bIns="18288" anchor="t">
-            <a:spAutoFit/>
+          <a:bodyPr wrap="square" lIns="18288" rIns="18288" tIns="18288" bIns="18288" anchor="t">
+            <a:normAutofit/>
           </a:bodyPr>
           <a:lstStyle/>
           <a:p>
@@ -5414,8 +5414,8 @@
           <a:noFill/>
         </p:spPr>
         <p:txBody>
-          <a:bodyPr wrap="none" lIns="18288" rIns="18288" tIns="18288" bIns="18288" anchor="t">
-            <a:spAutoFit/>
+          <a:bodyPr wrap="square" lIns="18288" rIns="18288" tIns="18288" bIns="18288" anchor="t">
+            <a:normAutofit/>
           </a:bodyPr>
           <a:lstStyle/>
           <a:p>
@@ -5449,8 +5449,8 @@
           <a:noFill/>
         </p:spPr>
         <p:txBody>
-          <a:bodyPr wrap="none" lIns="18288" rIns="18288" tIns="18288" bIns="18288" anchor="t">
-            <a:spAutoFit/>
+          <a:bodyPr wrap="square" lIns="18288" rIns="18288" tIns="18288" bIns="18288" anchor="t">
+            <a:normAutofit/>
           </a:bodyPr>
           <a:lstStyle/>
           <a:p>
@@ -5510,8 +5510,8 @@
           <a:noFill/>
         </p:spPr>
         <p:txBody>
-          <a:bodyPr wrap="none" lIns="18288" rIns="18288" tIns="18288" bIns="18288" anchor="t">
-            <a:spAutoFit/>
+          <a:bodyPr wrap="square" lIns="18288" rIns="18288" tIns="18288" bIns="18288" anchor="t">
+            <a:normAutofit/>
           </a:bodyPr>
           <a:lstStyle/>
           <a:p>
@@ -5545,8 +5545,8 @@
           <a:noFill/>
         </p:spPr>
         <p:txBody>
-          <a:bodyPr wrap="none" lIns="18288" rIns="18288" tIns="18288" bIns="18288" anchor="t">
-            <a:spAutoFit/>
+          <a:bodyPr wrap="square" lIns="18288" rIns="18288" tIns="18288" bIns="18288" anchor="t">
+            <a:normAutofit/>
           </a:bodyPr>
           <a:lstStyle/>
           <a:p>
@@ -5623,8 +5623,8 @@
           <a:noFill/>
         </p:spPr>
         <p:txBody>
-          <a:bodyPr wrap="none" lIns="18288" rIns="18288" tIns="18288" bIns="18288" anchor="t">
-            <a:spAutoFit/>
+          <a:bodyPr wrap="square" lIns="18288" rIns="18288" tIns="18288" bIns="18288" anchor="t">
+            <a:normAutofit/>
           </a:bodyPr>
           <a:lstStyle/>
           <a:p>
@@ -5658,8 +5658,8 @@
           <a:noFill/>
         </p:spPr>
         <p:txBody>
-          <a:bodyPr wrap="none" lIns="18288" rIns="18288" tIns="18288" bIns="18288" anchor="t">
-            <a:spAutoFit/>
+          <a:bodyPr wrap="square" lIns="18288" rIns="18288" tIns="18288" bIns="18288" anchor="t">
+            <a:normAutofit/>
           </a:bodyPr>
           <a:lstStyle/>
           <a:p>
@@ -5736,8 +5736,8 @@
           <a:noFill/>
         </p:spPr>
         <p:txBody>
-          <a:bodyPr wrap="none" lIns="18288" rIns="18288" tIns="18288" bIns="18288" anchor="t">
-            <a:spAutoFit/>
+          <a:bodyPr wrap="square" lIns="18288" rIns="18288" tIns="18288" bIns="18288" anchor="t">
+            <a:normAutofit/>
           </a:bodyPr>
           <a:lstStyle/>
           <a:p>
@@ -5771,8 +5771,8 @@
           <a:noFill/>
         </p:spPr>
         <p:txBody>
-          <a:bodyPr wrap="none" lIns="18288" rIns="18288" tIns="18288" bIns="18288" anchor="t">
-            <a:spAutoFit/>
+          <a:bodyPr wrap="square" lIns="18288" rIns="18288" tIns="18288" bIns="18288" anchor="t">
+            <a:normAutofit/>
           </a:bodyPr>
           <a:lstStyle/>
           <a:p>
@@ -5806,8 +5806,8 @@
           <a:noFill/>
         </p:spPr>
         <p:txBody>
-          <a:bodyPr wrap="none" lIns="18288" rIns="18288" tIns="18288" bIns="18288" anchor="t">
-            <a:spAutoFit/>
+          <a:bodyPr wrap="square" lIns="18288" rIns="18288" tIns="18288" bIns="18288" anchor="t">
+            <a:normAutofit/>
           </a:bodyPr>
           <a:lstStyle/>
           <a:p>
@@ -5884,8 +5884,8 @@
           <a:noFill/>
         </p:spPr>
         <p:txBody>
-          <a:bodyPr wrap="none" lIns="18288" rIns="18288" tIns="18288" bIns="18288" anchor="t">
-            <a:spAutoFit/>
+          <a:bodyPr wrap="square" lIns="18288" rIns="18288" tIns="18288" bIns="18288" anchor="t">
+            <a:normAutofit/>
           </a:bodyPr>
           <a:lstStyle/>
           <a:p>
@@ -5919,8 +5919,8 @@
           <a:noFill/>
         </p:spPr>
         <p:txBody>
-          <a:bodyPr wrap="none" lIns="18288" rIns="18288" tIns="18288" bIns="18288" anchor="t">
-            <a:spAutoFit/>
+          <a:bodyPr wrap="square" lIns="18288" rIns="18288" tIns="18288" bIns="18288" anchor="t">
+            <a:normAutofit/>
           </a:bodyPr>
           <a:lstStyle/>
           <a:p>
@@ -5954,8 +5954,8 @@
           <a:noFill/>
         </p:spPr>
         <p:txBody>
-          <a:bodyPr wrap="none" lIns="18288" rIns="18288" tIns="18288" bIns="18288" anchor="t">
-            <a:spAutoFit/>
+          <a:bodyPr wrap="square" lIns="18288" rIns="18288" tIns="18288" bIns="18288" anchor="t">
+            <a:normAutofit/>
           </a:bodyPr>
           <a:lstStyle/>
           <a:p>
@@ -6032,8 +6032,8 @@
           <a:noFill/>
         </p:spPr>
         <p:txBody>
-          <a:bodyPr wrap="none" lIns="18288" rIns="18288" tIns="18288" bIns="18288" anchor="t">
-            <a:spAutoFit/>
+          <a:bodyPr wrap="square" lIns="18288" rIns="18288" tIns="18288" bIns="18288" anchor="t">
+            <a:normAutofit/>
           </a:bodyPr>
           <a:lstStyle/>
           <a:p>
@@ -6067,8 +6067,8 @@
           <a:noFill/>
         </p:spPr>
         <p:txBody>
-          <a:bodyPr wrap="none" lIns="18288" rIns="18288" tIns="18288" bIns="18288" anchor="t">
-            <a:spAutoFit/>
+          <a:bodyPr wrap="square" lIns="18288" rIns="18288" tIns="18288" bIns="18288" anchor="t">
+            <a:normAutofit/>
           </a:bodyPr>
           <a:lstStyle/>
           <a:p>
@@ -6258,8 +6258,8 @@
           <a:noFill/>
         </p:spPr>
         <p:txBody>
-          <a:bodyPr wrap="none" lIns="18288" rIns="18288" tIns="18288" bIns="18288" anchor="t">
-            <a:spAutoFit/>
+          <a:bodyPr wrap="square" lIns="18288" rIns="18288" tIns="18288" bIns="18288" anchor="t">
+            <a:normAutofit/>
           </a:bodyPr>
           <a:lstStyle/>
           <a:p>
@@ -6293,8 +6293,8 @@
           <a:noFill/>
         </p:spPr>
         <p:txBody>
-          <a:bodyPr wrap="none" lIns="18288" rIns="18288" tIns="18288" bIns="18288" anchor="t">
-            <a:spAutoFit/>
+          <a:bodyPr wrap="square" lIns="18288" rIns="18288" tIns="18288" bIns="18288" anchor="t">
+            <a:normAutofit/>
           </a:bodyPr>
           <a:lstStyle/>
           <a:p>
@@ -6354,8 +6354,8 @@
           <a:noFill/>
         </p:spPr>
         <p:txBody>
-          <a:bodyPr wrap="none" lIns="18288" rIns="18288" tIns="18288" bIns="18288" anchor="t">
-            <a:spAutoFit/>
+          <a:bodyPr wrap="square" lIns="18288" rIns="18288" tIns="18288" bIns="18288" anchor="t">
+            <a:normAutofit/>
           </a:bodyPr>
           <a:lstStyle/>
           <a:p>
@@ -6389,8 +6389,8 @@
           <a:noFill/>
         </p:spPr>
         <p:txBody>
-          <a:bodyPr wrap="none" lIns="18288" rIns="18288" tIns="18288" bIns="18288" anchor="t">
-            <a:spAutoFit/>
+          <a:bodyPr wrap="square" lIns="18288" rIns="18288" tIns="18288" bIns="18288" anchor="t">
+            <a:normAutofit/>
           </a:bodyPr>
           <a:lstStyle/>
           <a:p>
@@ -6512,8 +6512,8 @@
           <a:noFill/>
         </p:spPr>
         <p:txBody>
-          <a:bodyPr wrap="none" lIns="18288" rIns="18288" tIns="18288" bIns="18288" anchor="t">
-            <a:spAutoFit/>
+          <a:bodyPr wrap="square" lIns="18288" rIns="18288" tIns="18288" bIns="18288" anchor="t">
+            <a:normAutofit/>
           </a:bodyPr>
           <a:lstStyle/>
           <a:p>
@@ -6547,8 +6547,8 @@
           <a:noFill/>
         </p:spPr>
         <p:txBody>
-          <a:bodyPr wrap="none" lIns="18288" rIns="18288" tIns="18288" bIns="18288" anchor="t">
-            <a:spAutoFit/>
+          <a:bodyPr wrap="square" lIns="18288" rIns="18288" tIns="18288" bIns="18288" anchor="t">
+            <a:normAutofit/>
           </a:bodyPr>
           <a:lstStyle/>
           <a:p>
@@ -6583,8 +6583,8 @@
           <a:noFill/>
         </p:spPr>
         <p:txBody>
-          <a:bodyPr wrap="none" lIns="18288" rIns="18288" tIns="18288" bIns="18288" anchor="t">
-            <a:spAutoFit/>
+          <a:bodyPr wrap="square" lIns="18288" rIns="18288" tIns="18288" bIns="18288" anchor="t">
+            <a:normAutofit/>
           </a:bodyPr>
           <a:lstStyle/>
           <a:p>
@@ -6663,8 +6663,8 @@
           <a:noFill/>
         </p:spPr>
         <p:txBody>
-          <a:bodyPr wrap="none" lIns="18288" rIns="18288" tIns="18288" bIns="18288" anchor="t">
-            <a:spAutoFit/>
+          <a:bodyPr wrap="square" lIns="18288" rIns="18288" tIns="18288" bIns="18288" anchor="t">
+            <a:normAutofit/>
           </a:bodyPr>
           <a:lstStyle/>
           <a:p>
@@ -6698,8 +6698,8 @@
           <a:noFill/>
         </p:spPr>
         <p:txBody>
-          <a:bodyPr wrap="none" lIns="18288" rIns="18288" tIns="18288" bIns="18288" anchor="t">
-            <a:spAutoFit/>
+          <a:bodyPr wrap="square" lIns="18288" rIns="18288" tIns="18288" bIns="18288" anchor="t">
+            <a:normAutofit/>
           </a:bodyPr>
           <a:lstStyle/>
           <a:p>
@@ -6734,8 +6734,8 @@
           <a:noFill/>
         </p:spPr>
         <p:txBody>
-          <a:bodyPr wrap="none" lIns="18288" rIns="18288" tIns="18288" bIns="18288" anchor="t">
-            <a:spAutoFit/>
+          <a:bodyPr wrap="square" lIns="18288" rIns="18288" tIns="18288" bIns="18288" anchor="t">
+            <a:normAutofit/>
           </a:bodyPr>
           <a:lstStyle/>
           <a:p>
@@ -6814,8 +6814,8 @@
           <a:noFill/>
         </p:spPr>
         <p:txBody>
-          <a:bodyPr wrap="none" lIns="18288" rIns="18288" tIns="18288" bIns="18288" anchor="t">
-            <a:spAutoFit/>
+          <a:bodyPr wrap="square" lIns="18288" rIns="18288" tIns="18288" bIns="18288" anchor="t">
+            <a:normAutofit/>
           </a:bodyPr>
           <a:lstStyle/>
           <a:p>
@@ -6849,8 +6849,8 @@
           <a:noFill/>
         </p:spPr>
         <p:txBody>
-          <a:bodyPr wrap="none" lIns="18288" rIns="18288" tIns="18288" bIns="18288" anchor="t">
-            <a:spAutoFit/>
+          <a:bodyPr wrap="square" lIns="18288" rIns="18288" tIns="18288" bIns="18288" anchor="t">
+            <a:normAutofit/>
           </a:bodyPr>
           <a:lstStyle/>
           <a:p>
@@ -6885,8 +6885,8 @@
           <a:noFill/>
         </p:spPr>
         <p:txBody>
-          <a:bodyPr wrap="none" lIns="18288" rIns="18288" tIns="18288" bIns="18288" anchor="t">
-            <a:spAutoFit/>
+          <a:bodyPr wrap="square" lIns="18288" rIns="18288" tIns="18288" bIns="18288" anchor="t">
+            <a:normAutofit/>
           </a:bodyPr>
           <a:lstStyle/>
           <a:p>
@@ -6965,8 +6965,8 @@
           <a:noFill/>
         </p:spPr>
         <p:txBody>
-          <a:bodyPr wrap="none" lIns="18288" rIns="18288" tIns="18288" bIns="18288" anchor="t">
-            <a:spAutoFit/>
+          <a:bodyPr wrap="square" lIns="18288" rIns="18288" tIns="18288" bIns="18288" anchor="t">
+            <a:normAutofit/>
           </a:bodyPr>
           <a:lstStyle/>
           <a:p>
@@ -7000,8 +7000,8 @@
           <a:noFill/>
         </p:spPr>
         <p:txBody>
-          <a:bodyPr wrap="none" lIns="18288" rIns="18288" tIns="18288" bIns="18288" anchor="t">
-            <a:spAutoFit/>
+          <a:bodyPr wrap="square" lIns="18288" rIns="18288" tIns="18288" bIns="18288" anchor="t">
+            <a:normAutofit/>
           </a:bodyPr>
           <a:lstStyle/>
           <a:p>
@@ -7036,8 +7036,8 @@
           <a:noFill/>
         </p:spPr>
         <p:txBody>
-          <a:bodyPr wrap="none" lIns="18288" rIns="18288" tIns="18288" bIns="18288" anchor="t">
-            <a:spAutoFit/>
+          <a:bodyPr wrap="square" lIns="18288" rIns="18288" tIns="18288" bIns="18288" anchor="t">
+            <a:normAutofit/>
           </a:bodyPr>
           <a:lstStyle/>
           <a:p>
@@ -7116,8 +7116,8 @@
           <a:noFill/>
         </p:spPr>
         <p:txBody>
-          <a:bodyPr wrap="none" lIns="18288" rIns="18288" tIns="18288" bIns="18288" anchor="t">
-            <a:spAutoFit/>
+          <a:bodyPr wrap="square" lIns="18288" rIns="18288" tIns="18288" bIns="18288" anchor="t">
+            <a:normAutofit/>
           </a:bodyPr>
           <a:lstStyle/>
           <a:p>
@@ -7151,8 +7151,8 @@
           <a:noFill/>
         </p:spPr>
         <p:txBody>
-          <a:bodyPr wrap="none" lIns="18288" rIns="18288" tIns="18288" bIns="18288" anchor="t">
-            <a:spAutoFit/>
+          <a:bodyPr wrap="square" lIns="18288" rIns="18288" tIns="18288" bIns="18288" anchor="t">
+            <a:normAutofit/>
           </a:bodyPr>
           <a:lstStyle/>
           <a:p>
@@ -7187,8 +7187,8 @@
           <a:noFill/>
         </p:spPr>
         <p:txBody>
-          <a:bodyPr wrap="none" lIns="18288" rIns="18288" tIns="18288" bIns="18288" anchor="t">
-            <a:spAutoFit/>
+          <a:bodyPr wrap="square" lIns="18288" rIns="18288" tIns="18288" bIns="18288" anchor="t">
+            <a:normAutofit/>
           </a:bodyPr>
           <a:lstStyle/>
           <a:p>
@@ -7222,8 +7222,8 @@
           <a:noFill/>
         </p:spPr>
         <p:txBody>
-          <a:bodyPr wrap="none" lIns="18288" rIns="18288" tIns="18288" bIns="18288" anchor="t">
-            <a:spAutoFit/>
+          <a:bodyPr wrap="square" lIns="18288" rIns="18288" tIns="18288" bIns="18288" anchor="t">
+            <a:normAutofit/>
           </a:bodyPr>
           <a:lstStyle/>
           <a:p>
@@ -7257,8 +7257,8 @@
           <a:noFill/>
         </p:spPr>
         <p:txBody>
-          <a:bodyPr wrap="none" lIns="18288" rIns="18288" tIns="18288" bIns="18288" anchor="t">
-            <a:spAutoFit/>
+          <a:bodyPr wrap="square" lIns="18288" rIns="18288" tIns="18288" bIns="18288" anchor="t">
+            <a:normAutofit/>
           </a:bodyPr>
           <a:lstStyle/>
           <a:p>
@@ -7292,8 +7292,8 @@
           <a:noFill/>
         </p:spPr>
         <p:txBody>
-          <a:bodyPr wrap="none" lIns="18288" rIns="18288" tIns="18288" bIns="18288" anchor="t">
-            <a:spAutoFit/>
+          <a:bodyPr wrap="square" lIns="18288" rIns="18288" tIns="18288" bIns="18288" anchor="t">
+            <a:normAutofit/>
           </a:bodyPr>
           <a:lstStyle/>
           <a:p>
@@ -7327,8 +7327,8 @@
           <a:noFill/>
         </p:spPr>
         <p:txBody>
-          <a:bodyPr wrap="none" lIns="18288" rIns="18288" tIns="18288" bIns="18288" anchor="t">
-            <a:spAutoFit/>
+          <a:bodyPr wrap="square" lIns="18288" rIns="18288" tIns="18288" bIns="18288" anchor="t">
+            <a:normAutofit/>
           </a:bodyPr>
           <a:lstStyle/>
           <a:p>
@@ -7362,8 +7362,8 @@
           <a:noFill/>
         </p:spPr>
         <p:txBody>
-          <a:bodyPr wrap="none" lIns="18288" rIns="18288" tIns="18288" bIns="18288" anchor="t">
-            <a:spAutoFit/>
+          <a:bodyPr wrap="square" lIns="18288" rIns="18288" tIns="18288" bIns="18288" anchor="t">
+            <a:normAutofit/>
           </a:bodyPr>
           <a:lstStyle/>
           <a:p>
@@ -7423,8 +7423,8 @@
           <a:noFill/>
         </p:spPr>
         <p:txBody>
-          <a:bodyPr wrap="none" lIns="18288" rIns="18288" tIns="18288" bIns="18288" anchor="t">
-            <a:spAutoFit/>
+          <a:bodyPr wrap="square" lIns="18288" rIns="18288" tIns="18288" bIns="18288" anchor="t">
+            <a:normAutofit/>
           </a:bodyPr>
           <a:lstStyle/>
           <a:p>
@@ -7458,8 +7458,8 @@
           <a:noFill/>
         </p:spPr>
         <p:txBody>
-          <a:bodyPr wrap="none" lIns="18288" rIns="18288" tIns="18288" bIns="18288" anchor="t">
-            <a:spAutoFit/>
+          <a:bodyPr wrap="square" lIns="18288" rIns="18288" tIns="18288" bIns="18288" anchor="t">
+            <a:normAutofit/>
           </a:bodyPr>
           <a:lstStyle/>
           <a:p>
@@ -7554,8 +7554,8 @@
           <a:noFill/>
         </p:spPr>
         <p:txBody>
-          <a:bodyPr wrap="none" lIns="18288" rIns="18288" tIns="18288" bIns="18288" anchor="t">
-            <a:spAutoFit/>
+          <a:bodyPr wrap="square" lIns="18288" rIns="18288" tIns="18288" bIns="18288" anchor="t">
+            <a:normAutofit/>
           </a:bodyPr>
           <a:lstStyle/>
           <a:p>
@@ -7589,8 +7589,8 @@
           <a:noFill/>
         </p:spPr>
         <p:txBody>
-          <a:bodyPr wrap="none" lIns="18288" rIns="18288" tIns="18288" bIns="18288" anchor="t">
-            <a:spAutoFit/>
+          <a:bodyPr wrap="square" lIns="18288" rIns="18288" tIns="18288" bIns="18288" anchor="t">
+            <a:normAutofit/>
           </a:bodyPr>
           <a:lstStyle/>
           <a:p>
@@ -7624,8 +7624,8 @@
           <a:noFill/>
         </p:spPr>
         <p:txBody>
-          <a:bodyPr wrap="none" lIns="18288" rIns="18288" tIns="18288" bIns="18288" anchor="t">
-            <a:spAutoFit/>
+          <a:bodyPr wrap="square" lIns="18288" rIns="18288" tIns="18288" bIns="18288" anchor="t">
+            <a:normAutofit/>
           </a:bodyPr>
           <a:lstStyle/>
           <a:p>
@@ -7659,8 +7659,8 @@
           <a:noFill/>
         </p:spPr>
         <p:txBody>
-          <a:bodyPr wrap="none" lIns="18288" rIns="18288" tIns="18288" bIns="18288" anchor="t">
-            <a:spAutoFit/>
+          <a:bodyPr wrap="square" lIns="18288" rIns="18288" tIns="18288" bIns="18288" anchor="t">
+            <a:normAutofit/>
           </a:bodyPr>
           <a:lstStyle/>
           <a:p>
@@ -7694,8 +7694,8 @@
           <a:noFill/>
         </p:spPr>
         <p:txBody>
-          <a:bodyPr wrap="none" lIns="18288" rIns="18288" tIns="18288" bIns="18288" anchor="t">
-            <a:spAutoFit/>
+          <a:bodyPr wrap="square" lIns="18288" rIns="18288" tIns="18288" bIns="18288" anchor="t">
+            <a:normAutofit/>
           </a:bodyPr>
           <a:lstStyle/>
           <a:p>
@@ -7729,8 +7729,8 @@
           <a:noFill/>
         </p:spPr>
         <p:txBody>
-          <a:bodyPr wrap="none" lIns="18288" rIns="18288" tIns="18288" bIns="18288" anchor="t">
-            <a:spAutoFit/>
+          <a:bodyPr wrap="square" lIns="18288" rIns="18288" tIns="18288" bIns="18288" anchor="t">
+            <a:normAutofit/>
           </a:bodyPr>
           <a:lstStyle/>
           <a:p>
@@ -7764,8 +7764,8 @@
           <a:noFill/>
         </p:spPr>
         <p:txBody>
-          <a:bodyPr wrap="none" lIns="18288" rIns="18288" tIns="18288" bIns="18288" anchor="t">
-            <a:spAutoFit/>
+          <a:bodyPr wrap="square" lIns="18288" rIns="18288" tIns="18288" bIns="18288" anchor="t">
+            <a:normAutofit/>
           </a:bodyPr>
           <a:lstStyle/>
           <a:p>
@@ -7799,8 +7799,8 @@
           <a:noFill/>
         </p:spPr>
         <p:txBody>
-          <a:bodyPr wrap="none" lIns="18288" rIns="18288" tIns="18288" bIns="18288" anchor="t">
-            <a:spAutoFit/>
+          <a:bodyPr wrap="square" lIns="18288" rIns="18288" tIns="18288" bIns="18288" anchor="t">
+            <a:normAutofit/>
           </a:bodyPr>
           <a:lstStyle/>
           <a:p>
@@ -7834,8 +7834,8 @@
           <a:noFill/>
         </p:spPr>
         <p:txBody>
-          <a:bodyPr wrap="none" lIns="18288" rIns="18288" tIns="18288" bIns="18288" anchor="t">
-            <a:spAutoFit/>
+          <a:bodyPr wrap="square" lIns="18288" rIns="18288" tIns="18288" bIns="18288" anchor="t">
+            <a:normAutofit/>
           </a:bodyPr>
           <a:lstStyle/>
           <a:p>
@@ -7914,8 +7914,8 @@
           <a:noFill/>
         </p:spPr>
         <p:txBody>
-          <a:bodyPr wrap="none" lIns="18288" rIns="18288" tIns="18288" bIns="18288" anchor="t">
-            <a:spAutoFit/>
+          <a:bodyPr wrap="square" lIns="18288" rIns="18288" tIns="18288" bIns="18288" anchor="t">
+            <a:normAutofit/>
           </a:bodyPr>
           <a:lstStyle/>
           <a:p>
@@ -7994,8 +7994,8 @@
           <a:noFill/>
         </p:spPr>
         <p:txBody>
-          <a:bodyPr wrap="none" lIns="18288" rIns="18288" tIns="18288" bIns="18288" anchor="t">
-            <a:spAutoFit/>
+          <a:bodyPr wrap="square" lIns="18288" rIns="18288" tIns="18288" bIns="18288" anchor="t">
+            <a:normAutofit/>
           </a:bodyPr>
           <a:lstStyle/>
           <a:p>
@@ -8074,8 +8074,8 @@
           <a:noFill/>
         </p:spPr>
         <p:txBody>
-          <a:bodyPr wrap="none" lIns="18288" rIns="18288" tIns="18288" bIns="18288" anchor="t">
-            <a:spAutoFit/>
+          <a:bodyPr wrap="square" lIns="18288" rIns="18288" tIns="18288" bIns="18288" anchor="t">
+            <a:normAutofit/>
           </a:bodyPr>
           <a:lstStyle/>
           <a:p>
@@ -8154,8 +8154,8 @@
           <a:noFill/>
         </p:spPr>
         <p:txBody>
-          <a:bodyPr wrap="none" lIns="18288" rIns="18288" tIns="18288" bIns="18288" anchor="t">
-            <a:spAutoFit/>
+          <a:bodyPr wrap="square" lIns="18288" rIns="18288" tIns="18288" bIns="18288" anchor="t">
+            <a:normAutofit/>
           </a:bodyPr>
           <a:lstStyle/>
           <a:p>
@@ -8234,8 +8234,8 @@
           <a:noFill/>
         </p:spPr>
         <p:txBody>
-          <a:bodyPr wrap="none" lIns="18288" rIns="18288" tIns="18288" bIns="18288" anchor="t">
-            <a:spAutoFit/>
+          <a:bodyPr wrap="square" lIns="18288" rIns="18288" tIns="18288" bIns="18288" anchor="t">
+            <a:normAutofit/>
           </a:bodyPr>
           <a:lstStyle/>
           <a:p>
@@ -8314,8 +8314,8 @@
           <a:noFill/>
         </p:spPr>
         <p:txBody>
-          <a:bodyPr wrap="none" lIns="18288" rIns="18288" tIns="18288" bIns="18288" anchor="t">
-            <a:spAutoFit/>
+          <a:bodyPr wrap="square" lIns="18288" rIns="18288" tIns="18288" bIns="18288" anchor="t">
+            <a:normAutofit/>
           </a:bodyPr>
           <a:lstStyle/>
           <a:p>
@@ -8394,8 +8394,8 @@
           <a:noFill/>
         </p:spPr>
         <p:txBody>
-          <a:bodyPr wrap="none" lIns="18288" rIns="18288" tIns="18288" bIns="18288" anchor="t">
-            <a:spAutoFit/>
+          <a:bodyPr wrap="square" lIns="18288" rIns="18288" tIns="18288" bIns="18288" anchor="t">
+            <a:normAutofit/>
           </a:bodyPr>
           <a:lstStyle/>
           <a:p>
@@ -8474,8 +8474,8 @@
           <a:noFill/>
         </p:spPr>
         <p:txBody>
-          <a:bodyPr wrap="none" lIns="18288" rIns="18288" tIns="18288" bIns="18288" anchor="t">
-            <a:spAutoFit/>
+          <a:bodyPr wrap="square" lIns="18288" rIns="18288" tIns="18288" bIns="18288" anchor="t">
+            <a:normAutofit/>
           </a:bodyPr>
           <a:lstStyle/>
           <a:p>
@@ -8554,8 +8554,8 @@
           <a:noFill/>
         </p:spPr>
         <p:txBody>
-          <a:bodyPr wrap="none" lIns="18288" rIns="18288" tIns="18288" bIns="18288" anchor="t">
-            <a:spAutoFit/>
+          <a:bodyPr wrap="square" lIns="18288" rIns="18288" tIns="18288" bIns="18288" anchor="t">
+            <a:normAutofit/>
           </a:bodyPr>
           <a:lstStyle/>
           <a:p>
@@ -8589,8 +8589,8 @@
           <a:noFill/>
         </p:spPr>
         <p:txBody>
-          <a:bodyPr wrap="none" lIns="18288" rIns="18288" tIns="18288" bIns="18288" anchor="t">
-            <a:spAutoFit/>
+          <a:bodyPr wrap="square" lIns="18288" rIns="18288" tIns="18288" bIns="18288" anchor="t">
+            <a:normAutofit/>
           </a:bodyPr>
           <a:lstStyle/>
           <a:p>
@@ -8624,8 +8624,8 @@
           <a:noFill/>
         </p:spPr>
         <p:txBody>
-          <a:bodyPr wrap="none" lIns="18288" rIns="18288" tIns="18288" bIns="18288" anchor="t">
-            <a:spAutoFit/>
+          <a:bodyPr wrap="square" lIns="18288" rIns="18288" tIns="18288" bIns="18288" anchor="t">
+            <a:normAutofit/>
           </a:bodyPr>
           <a:lstStyle/>
           <a:p>
@@ -8685,8 +8685,8 @@
           <a:noFill/>
         </p:spPr>
         <p:txBody>
-          <a:bodyPr wrap="none" lIns="18288" rIns="18288" tIns="18288" bIns="18288" anchor="t">
-            <a:spAutoFit/>
+          <a:bodyPr wrap="square" lIns="18288" rIns="18288" tIns="18288" bIns="18288" anchor="t">
+            <a:normAutofit/>
           </a:bodyPr>
           <a:lstStyle/>
           <a:p>
@@ -8720,8 +8720,8 @@
           <a:noFill/>
         </p:spPr>
         <p:txBody>
-          <a:bodyPr wrap="none" lIns="18288" rIns="18288" tIns="18288" bIns="18288" anchor="t">
-            <a:spAutoFit/>
+          <a:bodyPr wrap="square" lIns="18288" rIns="18288" tIns="18288" bIns="18288" anchor="t">
+            <a:normAutofit/>
           </a:bodyPr>
           <a:lstStyle/>
           <a:p>
@@ -8816,8 +8816,8 @@
           <a:noFill/>
         </p:spPr>
         <p:txBody>
-          <a:bodyPr wrap="none" lIns="18288" rIns="18288" tIns="18288" bIns="18288" anchor="t">
-            <a:spAutoFit/>
+          <a:bodyPr wrap="square" lIns="18288" rIns="18288" tIns="18288" bIns="18288" anchor="t">
+            <a:normAutofit/>
           </a:bodyPr>
           <a:lstStyle/>
           <a:p>
@@ -8851,8 +8851,8 @@
           <a:noFill/>
         </p:spPr>
         <p:txBody>
-          <a:bodyPr wrap="none" lIns="18288" rIns="18288" tIns="18288" bIns="18288" anchor="t">
-            <a:spAutoFit/>
+          <a:bodyPr wrap="square" lIns="18288" rIns="18288" tIns="18288" bIns="18288" anchor="t">
+            <a:normAutofit/>
           </a:bodyPr>
           <a:lstStyle/>
           <a:p>
@@ -8886,8 +8886,8 @@
           <a:noFill/>
         </p:spPr>
         <p:txBody>
-          <a:bodyPr wrap="none" lIns="18288" rIns="18288" tIns="18288" bIns="18288" anchor="t">
-            <a:spAutoFit/>
+          <a:bodyPr wrap="square" lIns="18288" rIns="18288" tIns="18288" bIns="18288" anchor="t">
+            <a:normAutofit/>
           </a:bodyPr>
           <a:lstStyle/>
           <a:p>
@@ -8921,8 +8921,8 @@
           <a:noFill/>
         </p:spPr>
         <p:txBody>
-          <a:bodyPr wrap="none" lIns="18288" rIns="18288" tIns="18288" bIns="18288" anchor="t">
-            <a:spAutoFit/>
+          <a:bodyPr wrap="square" lIns="18288" rIns="18288" tIns="18288" bIns="18288" anchor="t">
+            <a:normAutofit/>
           </a:bodyPr>
           <a:lstStyle/>
           <a:p>
@@ -8956,8 +8956,8 @@
           <a:noFill/>
         </p:spPr>
         <p:txBody>
-          <a:bodyPr wrap="none" lIns="18288" rIns="18288" tIns="18288" bIns="18288" anchor="t">
-            <a:spAutoFit/>
+          <a:bodyPr wrap="square" lIns="18288" rIns="18288" tIns="18288" bIns="18288" anchor="t">
+            <a:normAutofit/>
           </a:bodyPr>
           <a:lstStyle/>
           <a:p>
@@ -8991,8 +8991,8 @@
           <a:noFill/>
         </p:spPr>
         <p:txBody>
-          <a:bodyPr wrap="none" lIns="18288" rIns="18288" tIns="18288" bIns="18288" anchor="t">
-            <a:spAutoFit/>
+          <a:bodyPr wrap="square" lIns="18288" rIns="18288" tIns="18288" bIns="18288" anchor="t">
+            <a:normAutofit/>
           </a:bodyPr>
           <a:lstStyle/>
           <a:p>
@@ -9026,8 +9026,8 @@
           <a:noFill/>
         </p:spPr>
         <p:txBody>
-          <a:bodyPr wrap="none" lIns="18288" rIns="18288" tIns="18288" bIns="18288" anchor="t">
-            <a:spAutoFit/>
+          <a:bodyPr wrap="square" lIns="18288" rIns="18288" tIns="18288" bIns="18288" anchor="t">
+            <a:normAutofit/>
           </a:bodyPr>
           <a:lstStyle/>
           <a:p>
@@ -9061,8 +9061,8 @@
           <a:noFill/>
         </p:spPr>
         <p:txBody>
-          <a:bodyPr wrap="none" lIns="18288" rIns="18288" tIns="18288" bIns="18288" anchor="t">
-            <a:spAutoFit/>
+          <a:bodyPr wrap="square" lIns="18288" rIns="18288" tIns="18288" bIns="18288" anchor="t">
+            <a:normAutofit/>
           </a:bodyPr>
           <a:lstStyle/>
           <a:p>
@@ -9096,8 +9096,8 @@
           <a:noFill/>
         </p:spPr>
         <p:txBody>
-          <a:bodyPr wrap="none" lIns="18288" rIns="18288" tIns="18288" bIns="18288" anchor="t">
-            <a:spAutoFit/>
+          <a:bodyPr wrap="square" lIns="18288" rIns="18288" tIns="18288" bIns="18288" anchor="t">
+            <a:normAutofit/>
           </a:bodyPr>
           <a:lstStyle/>
           <a:p>
@@ -9131,8 +9131,8 @@
           <a:noFill/>
         </p:spPr>
         <p:txBody>
-          <a:bodyPr wrap="none" lIns="18288" rIns="18288" tIns="18288" bIns="18288" anchor="t">
-            <a:spAutoFit/>
+          <a:bodyPr wrap="square" lIns="18288" rIns="18288" tIns="18288" bIns="18288" anchor="t">
+            <a:normAutofit/>
           </a:bodyPr>
           <a:lstStyle/>
           <a:p>
@@ -9192,8 +9192,8 @@
           <a:noFill/>
         </p:spPr>
         <p:txBody>
-          <a:bodyPr wrap="none" lIns="18288" rIns="18288" tIns="18288" bIns="18288" anchor="t">
-            <a:spAutoFit/>
+          <a:bodyPr wrap="square" lIns="18288" rIns="18288" tIns="18288" bIns="18288" anchor="t">
+            <a:normAutofit/>
           </a:bodyPr>
           <a:lstStyle/>
           <a:p>
@@ -9227,8 +9227,8 @@
           <a:noFill/>
         </p:spPr>
         <p:txBody>
-          <a:bodyPr wrap="none" lIns="18288" rIns="18288" tIns="18288" bIns="18288" anchor="t">
-            <a:spAutoFit/>
+          <a:bodyPr wrap="square" lIns="18288" rIns="18288" tIns="18288" bIns="18288" anchor="t">
+            <a:normAutofit/>
           </a:bodyPr>
           <a:lstStyle/>
           <a:p>
@@ -9305,8 +9305,8 @@
           <a:noFill/>
         </p:spPr>
         <p:txBody>
-          <a:bodyPr wrap="none" lIns="18288" rIns="18288" tIns="18288" bIns="18288" anchor="t">
-            <a:spAutoFit/>
+          <a:bodyPr wrap="square" lIns="18288" rIns="18288" tIns="18288" bIns="18288" anchor="t">
+            <a:normAutofit/>
           </a:bodyPr>
           <a:lstStyle/>
           <a:p>
@@ -9340,8 +9340,8 @@
           <a:noFill/>
         </p:spPr>
         <p:txBody>
-          <a:bodyPr wrap="none" lIns="18288" rIns="18288" tIns="18288" bIns="18288" anchor="t">
-            <a:spAutoFit/>
+          <a:bodyPr wrap="square" lIns="18288" rIns="18288" tIns="18288" bIns="18288" anchor="t">
+            <a:normAutofit/>
           </a:bodyPr>
           <a:lstStyle/>
           <a:p>
@@ -9375,8 +9375,8 @@
           <a:noFill/>
         </p:spPr>
         <p:txBody>
-          <a:bodyPr wrap="none" lIns="18288" rIns="18288" tIns="18288" bIns="18288" anchor="t">
-            <a:spAutoFit/>
+          <a:bodyPr wrap="square" lIns="18288" rIns="18288" tIns="18288" bIns="18288" anchor="t">
+            <a:normAutofit/>
           </a:bodyPr>
           <a:lstStyle/>
           <a:p>
@@ -9410,8 +9410,8 @@
           <a:noFill/>
         </p:spPr>
         <p:txBody>
-          <a:bodyPr wrap="none" lIns="18288" rIns="18288" tIns="18288" bIns="18288" anchor="t">
-            <a:spAutoFit/>
+          <a:bodyPr wrap="square" lIns="18288" rIns="18288" tIns="18288" bIns="18288" anchor="t">
+            <a:normAutofit/>
           </a:bodyPr>
           <a:lstStyle/>
           <a:p>
@@ -9445,8 +9445,8 @@
           <a:noFill/>
         </p:spPr>
         <p:txBody>
-          <a:bodyPr wrap="none" lIns="18288" rIns="18288" tIns="18288" bIns="18288" anchor="t">
-            <a:spAutoFit/>
+          <a:bodyPr wrap="square" lIns="18288" rIns="18288" tIns="18288" bIns="18288" anchor="t">
+            <a:normAutofit/>
           </a:bodyPr>
           <a:lstStyle/>
           <a:p>
@@ -9480,8 +9480,8 @@
           <a:noFill/>
         </p:spPr>
         <p:txBody>
-          <a:bodyPr wrap="none" lIns="18288" rIns="18288" tIns="18288" bIns="18288" anchor="t">
-            <a:spAutoFit/>
+          <a:bodyPr wrap="square" lIns="18288" rIns="18288" tIns="18288" bIns="18288" anchor="t">
+            <a:normAutofit/>
           </a:bodyPr>
           <a:lstStyle/>
           <a:p>
@@ -9515,8 +9515,8 @@
           <a:noFill/>
         </p:spPr>
         <p:txBody>
-          <a:bodyPr wrap="none" lIns="18288" rIns="18288" tIns="18288" bIns="18288" anchor="t">
-            <a:spAutoFit/>
+          <a:bodyPr wrap="square" lIns="18288" rIns="18288" tIns="18288" bIns="18288" anchor="t">
+            <a:normAutofit/>
           </a:bodyPr>
           <a:lstStyle/>
           <a:p>
@@ -9550,8 +9550,8 @@
           <a:noFill/>
         </p:spPr>
         <p:txBody>
-          <a:bodyPr wrap="none" lIns="18288" rIns="18288" tIns="18288" bIns="18288" anchor="t">
-            <a:spAutoFit/>
+          <a:bodyPr wrap="square" lIns="18288" rIns="18288" tIns="18288" bIns="18288" anchor="t">
+            <a:normAutofit/>
           </a:bodyPr>
           <a:lstStyle/>
           <a:p>
@@ -9585,8 +9585,8 @@
           <a:noFill/>
         </p:spPr>
         <p:txBody>
-          <a:bodyPr wrap="none" lIns="18288" rIns="18288" tIns="18288" bIns="18288" anchor="t">
-            <a:spAutoFit/>
+          <a:bodyPr wrap="square" lIns="18288" rIns="18288" tIns="18288" bIns="18288" anchor="t">
+            <a:normAutofit/>
           </a:bodyPr>
           <a:lstStyle/>
           <a:p>
@@ -9665,8 +9665,8 @@
           <a:noFill/>
         </p:spPr>
         <p:txBody>
-          <a:bodyPr wrap="none" lIns="18288" rIns="18288" tIns="18288" bIns="18288" anchor="t">
-            <a:spAutoFit/>
+          <a:bodyPr wrap="square" lIns="18288" rIns="18288" tIns="18288" bIns="18288" anchor="t">
+            <a:normAutofit/>
           </a:bodyPr>
           <a:lstStyle/>
           <a:p>
@@ -9745,8 +9745,8 @@
           <a:noFill/>
         </p:spPr>
         <p:txBody>
-          <a:bodyPr wrap="none" lIns="18288" rIns="18288" tIns="18288" bIns="18288" anchor="t">
-            <a:spAutoFit/>
+          <a:bodyPr wrap="square" lIns="18288" rIns="18288" tIns="18288" bIns="18288" anchor="t">
+            <a:normAutofit/>
           </a:bodyPr>
           <a:lstStyle/>
           <a:p>
@@ -9825,8 +9825,8 @@
           <a:noFill/>
         </p:spPr>
         <p:txBody>
-          <a:bodyPr wrap="none" lIns="18288" rIns="18288" tIns="18288" bIns="18288" anchor="t">
-            <a:spAutoFit/>
+          <a:bodyPr wrap="square" lIns="18288" rIns="18288" tIns="18288" bIns="18288" anchor="t">
+            <a:normAutofit/>
           </a:bodyPr>
           <a:lstStyle/>
           <a:p>
@@ -9905,8 +9905,8 @@
           <a:noFill/>
         </p:spPr>
         <p:txBody>
-          <a:bodyPr wrap="none" lIns="18288" rIns="18288" tIns="18288" bIns="18288" anchor="t">
-            <a:spAutoFit/>
+          <a:bodyPr wrap="square" lIns="18288" rIns="18288" tIns="18288" bIns="18288" anchor="t">
+            <a:normAutofit/>
           </a:bodyPr>
           <a:lstStyle/>
           <a:p>
@@ -9985,8 +9985,8 @@
           <a:noFill/>
         </p:spPr>
         <p:txBody>
-          <a:bodyPr wrap="none" lIns="18288" rIns="18288" tIns="18288" bIns="18288" anchor="t">
-            <a:spAutoFit/>
+          <a:bodyPr wrap="square" lIns="18288" rIns="18288" tIns="18288" bIns="18288" anchor="t">
+            <a:normAutofit/>
           </a:bodyPr>
           <a:lstStyle/>
           <a:p>
@@ -10065,8 +10065,8 @@
           <a:noFill/>
         </p:spPr>
         <p:txBody>
-          <a:bodyPr wrap="none" lIns="18288" rIns="18288" tIns="18288" bIns="18288" anchor="t">
-            <a:spAutoFit/>
+          <a:bodyPr wrap="square" lIns="18288" rIns="18288" tIns="18288" bIns="18288" anchor="t">
+            <a:normAutofit/>
           </a:bodyPr>
           <a:lstStyle/>
           <a:p>
@@ -10145,8 +10145,8 @@
           <a:noFill/>
         </p:spPr>
         <p:txBody>
-          <a:bodyPr wrap="none" lIns="18288" rIns="18288" tIns="18288" bIns="18288" anchor="t">
-            <a:spAutoFit/>
+          <a:bodyPr wrap="square" lIns="18288" rIns="18288" tIns="18288" bIns="18288" anchor="t">
+            <a:normAutofit/>
           </a:bodyPr>
           <a:lstStyle/>
           <a:p>
@@ -10180,8 +10180,8 @@
           <a:noFill/>
         </p:spPr>
         <p:txBody>
-          <a:bodyPr wrap="none" lIns="18288" rIns="18288" tIns="18288" bIns="18288" anchor="t">
-            <a:spAutoFit/>
+          <a:bodyPr wrap="square" lIns="18288" rIns="18288" tIns="18288" bIns="18288" anchor="t">
+            <a:normAutofit/>
           </a:bodyPr>
           <a:lstStyle/>
           <a:p>
@@ -10260,8 +10260,8 @@
           <a:noFill/>
         </p:spPr>
         <p:txBody>
-          <a:bodyPr wrap="none" lIns="18288" rIns="18288" tIns="18288" bIns="18288" anchor="t">
-            <a:spAutoFit/>
+          <a:bodyPr wrap="square" lIns="18288" rIns="18288" tIns="18288" bIns="18288" anchor="t">
+            <a:normAutofit/>
           </a:bodyPr>
           <a:lstStyle/>
           <a:p>
@@ -10340,8 +10340,8 @@
           <a:noFill/>
         </p:spPr>
         <p:txBody>
-          <a:bodyPr wrap="none" lIns="18288" rIns="18288" tIns="18288" bIns="18288" anchor="t">
-            <a:spAutoFit/>
+          <a:bodyPr wrap="square" lIns="18288" rIns="18288" tIns="18288" bIns="18288" anchor="t">
+            <a:normAutofit/>
           </a:bodyPr>
           <a:lstStyle/>
           <a:p>
@@ -10420,8 +10420,8 @@
           <a:noFill/>
         </p:spPr>
         <p:txBody>
-          <a:bodyPr wrap="none" lIns="18288" rIns="18288" tIns="18288" bIns="18288" anchor="t">
-            <a:spAutoFit/>
+          <a:bodyPr wrap="square" lIns="18288" rIns="18288" tIns="18288" bIns="18288" anchor="t">
+            <a:normAutofit/>
           </a:bodyPr>
           <a:lstStyle/>
           <a:p>
@@ -10500,8 +10500,8 @@
           <a:noFill/>
         </p:spPr>
         <p:txBody>
-          <a:bodyPr wrap="none" lIns="18288" rIns="18288" tIns="18288" bIns="18288" anchor="t">
-            <a:spAutoFit/>
+          <a:bodyPr wrap="square" lIns="18288" rIns="18288" tIns="18288" bIns="18288" anchor="t">
+            <a:normAutofit/>
           </a:bodyPr>
           <a:lstStyle/>
           <a:p>
@@ -10580,8 +10580,8 @@
           <a:noFill/>
         </p:spPr>
         <p:txBody>
-          <a:bodyPr wrap="none" lIns="18288" rIns="18288" tIns="18288" bIns="18288" anchor="t">
-            <a:spAutoFit/>
+          <a:bodyPr wrap="square" lIns="18288" rIns="18288" tIns="18288" bIns="18288" anchor="t">
+            <a:normAutofit/>
           </a:bodyPr>
           <a:lstStyle/>
           <a:p>
@@ -10660,8 +10660,8 @@
           <a:noFill/>
         </p:spPr>
         <p:txBody>
-          <a:bodyPr wrap="none" lIns="18288" rIns="18288" tIns="18288" bIns="18288" anchor="t">
-            <a:spAutoFit/>
+          <a:bodyPr wrap="square" lIns="18288" rIns="18288" tIns="18288" bIns="18288" anchor="t">
+            <a:normAutofit/>
           </a:bodyPr>
           <a:lstStyle/>
           <a:p>
@@ -10740,8 +10740,8 @@
           <a:noFill/>
         </p:spPr>
         <p:txBody>
-          <a:bodyPr wrap="none" lIns="18288" rIns="18288" tIns="18288" bIns="18288" anchor="t">
-            <a:spAutoFit/>
+          <a:bodyPr wrap="square" lIns="18288" rIns="18288" tIns="18288" bIns="18288" anchor="t">
+            <a:normAutofit/>
           </a:bodyPr>
           <a:lstStyle/>
           <a:p>
@@ -10775,8 +10775,8 @@
           <a:noFill/>
         </p:spPr>
         <p:txBody>
-          <a:bodyPr wrap="none" lIns="18288" rIns="18288" tIns="18288" bIns="18288" anchor="t">
-            <a:spAutoFit/>
+          <a:bodyPr wrap="square" lIns="18288" rIns="18288" tIns="18288" bIns="18288" anchor="t">
+            <a:normAutofit/>
           </a:bodyPr>
           <a:lstStyle/>
           <a:p>
@@ -10855,8 +10855,8 @@
           <a:noFill/>
         </p:spPr>
         <p:txBody>
-          <a:bodyPr wrap="none" lIns="18288" rIns="18288" tIns="18288" bIns="18288" anchor="t">
-            <a:spAutoFit/>
+          <a:bodyPr wrap="square" lIns="18288" rIns="18288" tIns="18288" bIns="18288" anchor="t">
+            <a:normAutofit/>
           </a:bodyPr>
           <a:lstStyle/>
           <a:p>
@@ -10935,8 +10935,8 @@
           <a:noFill/>
         </p:spPr>
         <p:txBody>
-          <a:bodyPr wrap="none" lIns="18288" rIns="18288" tIns="18288" bIns="18288" anchor="t">
-            <a:spAutoFit/>
+          <a:bodyPr wrap="square" lIns="18288" rIns="18288" tIns="18288" bIns="18288" anchor="t">
+            <a:normAutofit/>
           </a:bodyPr>
           <a:lstStyle/>
           <a:p>
@@ -11015,8 +11015,8 @@
           <a:noFill/>
         </p:spPr>
         <p:txBody>
-          <a:bodyPr wrap="none" lIns="18288" rIns="18288" tIns="18288" bIns="18288" anchor="t">
-            <a:spAutoFit/>
+          <a:bodyPr wrap="square" lIns="18288" rIns="18288" tIns="18288" bIns="18288" anchor="t">
+            <a:normAutofit/>
           </a:bodyPr>
           <a:lstStyle/>
           <a:p>
@@ -11095,8 +11095,8 @@
           <a:noFill/>
         </p:spPr>
         <p:txBody>
-          <a:bodyPr wrap="none" lIns="18288" rIns="18288" tIns="18288" bIns="18288" anchor="t">
-            <a:spAutoFit/>
+          <a:bodyPr wrap="square" lIns="18288" rIns="18288" tIns="18288" bIns="18288" anchor="t">
+            <a:normAutofit/>
           </a:bodyPr>
           <a:lstStyle/>
           <a:p>
@@ -11175,8 +11175,8 @@
           <a:noFill/>
         </p:spPr>
         <p:txBody>
-          <a:bodyPr wrap="none" lIns="18288" rIns="18288" tIns="18288" bIns="18288" anchor="t">
-            <a:spAutoFit/>
+          <a:bodyPr wrap="square" lIns="18288" rIns="18288" tIns="18288" bIns="18288" anchor="t">
+            <a:normAutofit/>
           </a:bodyPr>
           <a:lstStyle/>
           <a:p>
@@ -11255,8 +11255,8 @@
           <a:noFill/>
         </p:spPr>
         <p:txBody>
-          <a:bodyPr wrap="none" lIns="18288" rIns="18288" tIns="18288" bIns="18288" anchor="t">
-            <a:spAutoFit/>
+          <a:bodyPr wrap="square" lIns="18288" rIns="18288" tIns="18288" bIns="18288" anchor="t">
+            <a:normAutofit/>
           </a:bodyPr>
           <a:lstStyle/>
           <a:p>
@@ -11335,8 +11335,8 @@
           <a:noFill/>
         </p:spPr>
         <p:txBody>
-          <a:bodyPr wrap="none" lIns="18288" rIns="18288" tIns="18288" bIns="18288" anchor="t">
-            <a:spAutoFit/>
+          <a:bodyPr wrap="square" lIns="18288" rIns="18288" tIns="18288" bIns="18288" anchor="t">
+            <a:normAutofit/>
           </a:bodyPr>
           <a:lstStyle/>
           <a:p>
@@ -11370,8 +11370,8 @@
           <a:noFill/>
         </p:spPr>
         <p:txBody>
-          <a:bodyPr wrap="none" lIns="18288" rIns="18288" tIns="18288" bIns="18288" anchor="t">
-            <a:spAutoFit/>
+          <a:bodyPr wrap="square" lIns="18288" rIns="18288" tIns="18288" bIns="18288" anchor="t">
+            <a:normAutofit/>
           </a:bodyPr>
           <a:lstStyle/>
           <a:p>
@@ -11450,8 +11450,8 @@
           <a:noFill/>
         </p:spPr>
         <p:txBody>
-          <a:bodyPr wrap="none" lIns="18288" rIns="18288" tIns="18288" bIns="18288" anchor="t">
-            <a:spAutoFit/>
+          <a:bodyPr wrap="square" lIns="18288" rIns="18288" tIns="18288" bIns="18288" anchor="t">
+            <a:normAutofit/>
           </a:bodyPr>
           <a:lstStyle/>
           <a:p>
@@ -11530,8 +11530,8 @@
           <a:noFill/>
         </p:spPr>
         <p:txBody>
-          <a:bodyPr wrap="none" lIns="18288" rIns="18288" tIns="18288" bIns="18288" anchor="t">
-            <a:spAutoFit/>
+          <a:bodyPr wrap="square" lIns="18288" rIns="18288" tIns="18288" bIns="18288" anchor="t">
+            <a:normAutofit/>
           </a:bodyPr>
           <a:lstStyle/>
           <a:p>
@@ -11610,8 +11610,8 @@
           <a:noFill/>
         </p:spPr>
         <p:txBody>
-          <a:bodyPr wrap="none" lIns="18288" rIns="18288" tIns="18288" bIns="18288" anchor="t">
-            <a:spAutoFit/>
+          <a:bodyPr wrap="square" lIns="18288" rIns="18288" tIns="18288" bIns="18288" anchor="t">
+            <a:normAutofit/>
           </a:bodyPr>
           <a:lstStyle/>
           <a:p>
@@ -11690,8 +11690,8 @@
           <a:noFill/>
         </p:spPr>
         <p:txBody>
-          <a:bodyPr wrap="none" lIns="18288" rIns="18288" tIns="18288" bIns="18288" anchor="t">
-            <a:spAutoFit/>
+          <a:bodyPr wrap="square" lIns="18288" rIns="18288" tIns="18288" bIns="18288" anchor="t">
+            <a:normAutofit/>
           </a:bodyPr>
           <a:lstStyle/>
           <a:p>
@@ -11770,8 +11770,8 @@
           <a:noFill/>
         </p:spPr>
         <p:txBody>
-          <a:bodyPr wrap="none" lIns="18288" rIns="18288" tIns="18288" bIns="18288" anchor="t">
-            <a:spAutoFit/>
+          <a:bodyPr wrap="square" lIns="18288" rIns="18288" tIns="18288" bIns="18288" anchor="t">
+            <a:normAutofit/>
           </a:bodyPr>
           <a:lstStyle/>
           <a:p>
@@ -11850,8 +11850,8 @@
           <a:noFill/>
         </p:spPr>
         <p:txBody>
-          <a:bodyPr wrap="none" lIns="18288" rIns="18288" tIns="18288" bIns="18288" anchor="t">
-            <a:spAutoFit/>
+          <a:bodyPr wrap="square" lIns="18288" rIns="18288" tIns="18288" bIns="18288" anchor="t">
+            <a:normAutofit/>
           </a:bodyPr>
           <a:lstStyle/>
           <a:p>
@@ -11930,8 +11930,8 @@
           <a:noFill/>
         </p:spPr>
         <p:txBody>
-          <a:bodyPr wrap="none" lIns="18288" rIns="18288" tIns="18288" bIns="18288" anchor="t">
-            <a:spAutoFit/>
+          <a:bodyPr wrap="square" lIns="18288" rIns="18288" tIns="18288" bIns="18288" anchor="t">
+            <a:normAutofit/>
           </a:bodyPr>
           <a:lstStyle/>
           <a:p>
@@ -11965,8 +11965,8 @@
           <a:noFill/>
         </p:spPr>
         <p:txBody>
-          <a:bodyPr wrap="none" lIns="18288" rIns="18288" tIns="18288" bIns="18288" anchor="t">
-            <a:spAutoFit/>
+          <a:bodyPr wrap="square" lIns="18288" rIns="18288" tIns="18288" bIns="18288" anchor="t">
+            <a:normAutofit/>
           </a:bodyPr>
           <a:lstStyle/>
           <a:p>
@@ -12045,8 +12045,8 @@
           <a:noFill/>
         </p:spPr>
         <p:txBody>
-          <a:bodyPr wrap="none" lIns="18288" rIns="18288" tIns="18288" bIns="18288" anchor="t">
-            <a:spAutoFit/>
+          <a:bodyPr wrap="square" lIns="18288" rIns="18288" tIns="18288" bIns="18288" anchor="t">
+            <a:normAutofit/>
           </a:bodyPr>
           <a:lstStyle/>
           <a:p>
@@ -12125,8 +12125,8 @@
           <a:noFill/>
         </p:spPr>
         <p:txBody>
-          <a:bodyPr wrap="none" lIns="18288" rIns="18288" tIns="18288" bIns="18288" anchor="t">
-            <a:spAutoFit/>
+          <a:bodyPr wrap="square" lIns="18288" rIns="18288" tIns="18288" bIns="18288" anchor="t">
+            <a:normAutofit/>
           </a:bodyPr>
           <a:lstStyle/>
           <a:p>
@@ -12205,8 +12205,8 @@
           <a:noFill/>
         </p:spPr>
         <p:txBody>
-          <a:bodyPr wrap="none" lIns="18288" rIns="18288" tIns="18288" bIns="18288" anchor="t">
-            <a:spAutoFit/>
+          <a:bodyPr wrap="square" lIns="18288" rIns="18288" tIns="18288" bIns="18288" anchor="t">
+            <a:normAutofit/>
           </a:bodyPr>
           <a:lstStyle/>
           <a:p>
@@ -12285,8 +12285,8 @@
           <a:noFill/>
         </p:spPr>
         <p:txBody>
-          <a:bodyPr wrap="none" lIns="18288" rIns="18288" tIns="18288" bIns="18288" anchor="t">
-            <a:spAutoFit/>
+          <a:bodyPr wrap="square" lIns="18288" rIns="18288" tIns="18288" bIns="18288" anchor="t">
+            <a:normAutofit/>
           </a:bodyPr>
           <a:lstStyle/>
           <a:p>
@@ -12365,8 +12365,8 @@
           <a:noFill/>
         </p:spPr>
         <p:txBody>
-          <a:bodyPr wrap="none" lIns="18288" rIns="18288" tIns="18288" bIns="18288" anchor="t">
-            <a:spAutoFit/>
+          <a:bodyPr wrap="square" lIns="18288" rIns="18288" tIns="18288" bIns="18288" anchor="t">
+            <a:normAutofit/>
           </a:bodyPr>
           <a:lstStyle/>
           <a:p>
@@ -12445,8 +12445,8 @@
           <a:noFill/>
         </p:spPr>
         <p:txBody>
-          <a:bodyPr wrap="none" lIns="18288" rIns="18288" tIns="18288" bIns="18288" anchor="t">
-            <a:spAutoFit/>
+          <a:bodyPr wrap="square" lIns="18288" rIns="18288" tIns="18288" bIns="18288" anchor="t">
+            <a:normAutofit/>
           </a:bodyPr>
           <a:lstStyle/>
           <a:p>
@@ -12525,8 +12525,8 @@
           <a:noFill/>
         </p:spPr>
         <p:txBody>
-          <a:bodyPr wrap="none" lIns="18288" rIns="18288" tIns="18288" bIns="18288" anchor="t">
-            <a:spAutoFit/>
+          <a:bodyPr wrap="square" lIns="18288" rIns="18288" tIns="18288" bIns="18288" anchor="t">
+            <a:normAutofit/>
           </a:bodyPr>
           <a:lstStyle/>
           <a:p>
@@ -12560,8 +12560,8 @@
           <a:noFill/>
         </p:spPr>
         <p:txBody>
-          <a:bodyPr wrap="none" lIns="18288" rIns="18288" tIns="18288" bIns="18288" anchor="t">
-            <a:spAutoFit/>
+          <a:bodyPr wrap="square" lIns="18288" rIns="18288" tIns="18288" bIns="18288" anchor="t">
+            <a:normAutofit/>
           </a:bodyPr>
           <a:lstStyle/>
           <a:p>
@@ -12595,8 +12595,8 @@
           <a:noFill/>
         </p:spPr>
         <p:txBody>
-          <a:bodyPr wrap="none" lIns="18288" rIns="18288" tIns="18288" bIns="18288" anchor="t">
-            <a:spAutoFit/>
+          <a:bodyPr wrap="square" lIns="18288" rIns="18288" tIns="18288" bIns="18288" anchor="t">
+            <a:normAutofit/>
           </a:bodyPr>
           <a:lstStyle/>
           <a:p>
@@ -12630,8 +12630,8 @@
           <a:noFill/>
         </p:spPr>
         <p:txBody>
-          <a:bodyPr wrap="none" lIns="18288" rIns="18288" tIns="18288" bIns="18288" anchor="t">
-            <a:spAutoFit/>
+          <a:bodyPr wrap="square" lIns="18288" rIns="18288" tIns="18288" bIns="18288" anchor="t">
+            <a:normAutofit/>
           </a:bodyPr>
           <a:lstStyle/>
           <a:p>
@@ -12665,8 +12665,8 @@
           <a:noFill/>
         </p:spPr>
         <p:txBody>
-          <a:bodyPr wrap="none" lIns="18288" rIns="18288" tIns="18288" bIns="18288" anchor="t">
-            <a:spAutoFit/>
+          <a:bodyPr wrap="square" lIns="18288" rIns="18288" tIns="18288" bIns="18288" anchor="t">
+            <a:normAutofit/>
           </a:bodyPr>
           <a:lstStyle/>
           <a:p>
@@ -12700,8 +12700,8 @@
           <a:noFill/>
         </p:spPr>
         <p:txBody>
-          <a:bodyPr wrap="none" lIns="18288" rIns="18288" tIns="18288" bIns="18288" anchor="t">
-            <a:spAutoFit/>
+          <a:bodyPr wrap="square" lIns="18288" rIns="18288" tIns="18288" bIns="18288" anchor="t">
+            <a:normAutofit/>
           </a:bodyPr>
           <a:lstStyle/>
           <a:p>
@@ -12735,8 +12735,8 @@
           <a:noFill/>
         </p:spPr>
         <p:txBody>
-          <a:bodyPr wrap="none" lIns="18288" rIns="18288" tIns="18288" bIns="18288" anchor="t">
-            <a:spAutoFit/>
+          <a:bodyPr wrap="square" lIns="18288" rIns="18288" tIns="18288" bIns="18288" anchor="t">
+            <a:normAutofit/>
           </a:bodyPr>
           <a:lstStyle/>
           <a:p>
@@ -12770,8 +12770,8 @@
           <a:noFill/>
         </p:spPr>
         <p:txBody>
-          <a:bodyPr wrap="none" lIns="18288" rIns="18288" tIns="18288" bIns="18288" anchor="t">
-            <a:spAutoFit/>
+          <a:bodyPr wrap="square" lIns="18288" rIns="18288" tIns="18288" bIns="18288" anchor="t">
+            <a:normAutofit/>
           </a:bodyPr>
           <a:lstStyle/>
           <a:p>
@@ -12831,8 +12831,8 @@
           <a:noFill/>
         </p:spPr>
         <p:txBody>
-          <a:bodyPr wrap="none" lIns="18288" rIns="18288" tIns="18288" bIns="18288" anchor="t">
-            <a:spAutoFit/>
+          <a:bodyPr wrap="square" lIns="18288" rIns="18288" tIns="18288" bIns="18288" anchor="t">
+            <a:normAutofit/>
           </a:bodyPr>
           <a:lstStyle/>
           <a:p>
@@ -12866,8 +12866,8 @@
           <a:noFill/>
         </p:spPr>
         <p:txBody>
-          <a:bodyPr wrap="none" lIns="18288" rIns="18288" tIns="18288" bIns="18288" anchor="t">
-            <a:spAutoFit/>
+          <a:bodyPr wrap="square" lIns="18288" rIns="18288" tIns="18288" bIns="18288" anchor="t">
+            <a:normAutofit/>
           </a:bodyPr>
           <a:lstStyle/>
           <a:p>
@@ -12980,8 +12980,8 @@
           <a:noFill/>
         </p:spPr>
         <p:txBody>
-          <a:bodyPr wrap="none" lIns="18288" rIns="18288" tIns="18288" bIns="18288" anchor="t">
-            <a:spAutoFit/>
+          <a:bodyPr wrap="square" lIns="18288" rIns="18288" tIns="18288" bIns="18288" anchor="t">
+            <a:normAutofit/>
           </a:bodyPr>
           <a:lstStyle/>
           <a:p>
@@ -13015,8 +13015,8 @@
           <a:noFill/>
         </p:spPr>
         <p:txBody>
-          <a:bodyPr wrap="none" lIns="18288" rIns="18288" tIns="18288" bIns="18288" anchor="t">
-            <a:spAutoFit/>
+          <a:bodyPr wrap="square" lIns="18288" rIns="18288" tIns="18288" bIns="18288" anchor="t">
+            <a:normAutofit/>
           </a:bodyPr>
           <a:lstStyle/>
           <a:p>
@@ -13050,8 +13050,8 @@
           <a:noFill/>
         </p:spPr>
         <p:txBody>
-          <a:bodyPr wrap="none" lIns="18288" rIns="18288" tIns="18288" bIns="18288" anchor="t">
-            <a:spAutoFit/>
+          <a:bodyPr wrap="square" lIns="18288" rIns="18288" tIns="18288" bIns="18288" anchor="t">
+            <a:normAutofit/>
           </a:bodyPr>
           <a:lstStyle/>
           <a:p>
@@ -13085,8 +13085,8 @@
           <a:noFill/>
         </p:spPr>
         <p:txBody>
-          <a:bodyPr wrap="none" lIns="18288" rIns="18288" tIns="18288" bIns="18288" anchor="t">
-            <a:spAutoFit/>
+          <a:bodyPr wrap="square" lIns="18288" rIns="18288" tIns="18288" bIns="18288" anchor="t">
+            <a:normAutofit/>
           </a:bodyPr>
           <a:lstStyle/>
           <a:p>
@@ -13120,8 +13120,8 @@
           <a:noFill/>
         </p:spPr>
         <p:txBody>
-          <a:bodyPr wrap="none" lIns="18288" rIns="18288" tIns="18288" bIns="18288" anchor="t">
-            <a:spAutoFit/>
+          <a:bodyPr wrap="square" lIns="18288" rIns="18288" tIns="18288" bIns="18288" anchor="t">
+            <a:normAutofit/>
           </a:bodyPr>
           <a:lstStyle/>
           <a:p>
@@ -13155,8 +13155,8 @@
           <a:noFill/>
         </p:spPr>
         <p:txBody>
-          <a:bodyPr wrap="none" lIns="18288" rIns="18288" tIns="18288" bIns="18288" anchor="t">
-            <a:spAutoFit/>
+          <a:bodyPr wrap="square" lIns="18288" rIns="18288" tIns="18288" bIns="18288" anchor="t">
+            <a:normAutofit/>
           </a:bodyPr>
           <a:lstStyle/>
           <a:p>
@@ -13216,8 +13216,8 @@
           <a:noFill/>
         </p:spPr>
         <p:txBody>
-          <a:bodyPr wrap="none" lIns="18288" rIns="18288" tIns="18288" bIns="18288" anchor="t">
-            <a:spAutoFit/>
+          <a:bodyPr wrap="square" lIns="18288" rIns="18288" tIns="18288" bIns="18288" anchor="t">
+            <a:normAutofit/>
           </a:bodyPr>
           <a:lstStyle/>
           <a:p>
@@ -13251,8 +13251,8 @@
           <a:noFill/>
         </p:spPr>
         <p:txBody>
-          <a:bodyPr wrap="none" lIns="18288" rIns="18288" tIns="18288" bIns="18288" anchor="t">
-            <a:spAutoFit/>
+          <a:bodyPr wrap="square" lIns="18288" rIns="18288" tIns="18288" bIns="18288" anchor="t">
+            <a:normAutofit/>
           </a:bodyPr>
           <a:lstStyle/>
           <a:p>
@@ -13329,8 +13329,8 @@
           <a:noFill/>
         </p:spPr>
         <p:txBody>
-          <a:bodyPr wrap="none" lIns="18288" rIns="18288" tIns="18288" bIns="18288" anchor="t">
-            <a:spAutoFit/>
+          <a:bodyPr wrap="square" lIns="18288" rIns="18288" tIns="18288" bIns="18288" anchor="t">
+            <a:normAutofit/>
           </a:bodyPr>
           <a:lstStyle/>
           <a:p>
@@ -13364,8 +13364,8 @@
           <a:noFill/>
         </p:spPr>
         <p:txBody>
-          <a:bodyPr wrap="none" lIns="18288" rIns="18288" tIns="18288" bIns="18288" anchor="t">
-            <a:spAutoFit/>
+          <a:bodyPr wrap="square" lIns="18288" rIns="18288" tIns="18288" bIns="18288" anchor="t">
+            <a:normAutofit/>
           </a:bodyPr>
           <a:lstStyle/>
           <a:p>
@@ -13399,8 +13399,8 @@
           <a:noFill/>
         </p:spPr>
         <p:txBody>
-          <a:bodyPr wrap="none" lIns="18288" rIns="18288" tIns="18288" bIns="18288" anchor="t">
-            <a:spAutoFit/>
+          <a:bodyPr wrap="square" lIns="18288" rIns="18288" tIns="18288" bIns="18288" anchor="t">
+            <a:normAutofit/>
           </a:bodyPr>
           <a:lstStyle/>
           <a:p>
@@ -13434,8 +13434,8 @@
           <a:noFill/>
         </p:spPr>
         <p:txBody>
-          <a:bodyPr wrap="none" lIns="18288" rIns="18288" tIns="18288" bIns="18288" anchor="t">
-            <a:spAutoFit/>
+          <a:bodyPr wrap="square" lIns="18288" rIns="18288" tIns="18288" bIns="18288" anchor="t">
+            <a:normAutofit/>
           </a:bodyPr>
           <a:lstStyle/>
           <a:p>
@@ -13469,8 +13469,8 @@
           <a:noFill/>
         </p:spPr>
         <p:txBody>
-          <a:bodyPr wrap="none" lIns="18288" rIns="18288" tIns="18288" bIns="18288" anchor="t">
-            <a:spAutoFit/>
+          <a:bodyPr wrap="square" lIns="18288" rIns="18288" tIns="18288" bIns="18288" anchor="t">
+            <a:normAutofit/>
           </a:bodyPr>
           <a:lstStyle/>
           <a:p>
@@ -13547,8 +13547,8 @@
           <a:noFill/>
         </p:spPr>
         <p:txBody>
-          <a:bodyPr wrap="none" lIns="18288" rIns="18288" tIns="18288" bIns="18288" anchor="t">
-            <a:spAutoFit/>
+          <a:bodyPr wrap="square" lIns="18288" rIns="18288" tIns="18288" bIns="18288" anchor="t">
+            <a:normAutofit/>
           </a:bodyPr>
           <a:lstStyle/>
           <a:p>
@@ -13582,8 +13582,8 @@
           <a:noFill/>
         </p:spPr>
         <p:txBody>
-          <a:bodyPr wrap="none" lIns="18288" rIns="18288" tIns="18288" bIns="18288" anchor="t">
-            <a:spAutoFit/>
+          <a:bodyPr wrap="square" lIns="18288" rIns="18288" tIns="18288" bIns="18288" anchor="t">
+            <a:normAutofit/>
           </a:bodyPr>
           <a:lstStyle/>
           <a:p>
@@ -13617,8 +13617,8 @@
           <a:noFill/>
         </p:spPr>
         <p:txBody>
-          <a:bodyPr wrap="none" lIns="18288" rIns="18288" tIns="18288" bIns="18288" anchor="t">
-            <a:spAutoFit/>
+          <a:bodyPr wrap="square" lIns="18288" rIns="18288" tIns="18288" bIns="18288" anchor="t">
+            <a:normAutofit/>
           </a:bodyPr>
           <a:lstStyle/>
           <a:p>
@@ -13652,8 +13652,8 @@
           <a:noFill/>
         </p:spPr>
         <p:txBody>
-          <a:bodyPr wrap="none" lIns="18288" rIns="18288" tIns="18288" bIns="18288" anchor="t">
-            <a:spAutoFit/>
+          <a:bodyPr wrap="square" lIns="18288" rIns="18288" tIns="18288" bIns="18288" anchor="t">
+            <a:normAutofit/>
           </a:bodyPr>
           <a:lstStyle/>
           <a:p>
@@ -13730,8 +13730,8 @@
           <a:noFill/>
         </p:spPr>
         <p:txBody>
-          <a:bodyPr wrap="none" lIns="18288" rIns="18288" tIns="18288" bIns="18288" anchor="t">
-            <a:spAutoFit/>
+          <a:bodyPr wrap="square" lIns="18288" rIns="18288" tIns="18288" bIns="18288" anchor="t">
+            <a:normAutofit/>
           </a:bodyPr>
           <a:lstStyle/>
           <a:p>
@@ -13765,8 +13765,8 @@
           <a:noFill/>
         </p:spPr>
         <p:txBody>
-          <a:bodyPr wrap="none" lIns="18288" rIns="18288" tIns="18288" bIns="18288" anchor="t">
-            <a:spAutoFit/>
+          <a:bodyPr wrap="square" lIns="18288" rIns="18288" tIns="18288" bIns="18288" anchor="t">
+            <a:normAutofit/>
           </a:bodyPr>
           <a:lstStyle/>
           <a:p>
@@ -13800,8 +13800,8 @@
           <a:noFill/>
         </p:spPr>
         <p:txBody>
-          <a:bodyPr wrap="none" lIns="18288" rIns="18288" tIns="18288" bIns="18288" anchor="t">
-            <a:spAutoFit/>
+          <a:bodyPr wrap="square" lIns="18288" rIns="18288" tIns="18288" bIns="18288" anchor="t">
+            <a:normAutofit/>
           </a:bodyPr>
           <a:lstStyle/>
           <a:p>
@@ -13835,8 +13835,8 @@
           <a:noFill/>
         </p:spPr>
         <p:txBody>
-          <a:bodyPr wrap="none" lIns="18288" rIns="18288" tIns="18288" bIns="18288" anchor="t">
-            <a:spAutoFit/>
+          <a:bodyPr wrap="square" lIns="18288" rIns="18288" tIns="18288" bIns="18288" anchor="t">
+            <a:normAutofit/>
           </a:bodyPr>
           <a:lstStyle/>
           <a:p>
@@ -13913,8 +13913,8 @@
           <a:noFill/>
         </p:spPr>
         <p:txBody>
-          <a:bodyPr wrap="none" lIns="18288" rIns="18288" tIns="18288" bIns="18288" anchor="t">
-            <a:spAutoFit/>
+          <a:bodyPr wrap="square" lIns="18288" rIns="18288" tIns="18288" bIns="18288" anchor="t">
+            <a:normAutofit/>
           </a:bodyPr>
           <a:lstStyle/>
           <a:p>
@@ -13948,8 +13948,8 @@
           <a:noFill/>
         </p:spPr>
         <p:txBody>
-          <a:bodyPr wrap="none" lIns="18288" rIns="18288" tIns="18288" bIns="18288" anchor="t">
-            <a:spAutoFit/>
+          <a:bodyPr wrap="square" lIns="18288" rIns="18288" tIns="18288" bIns="18288" anchor="t">
+            <a:normAutofit/>
           </a:bodyPr>
           <a:lstStyle/>
           <a:p>
@@ -13983,8 +13983,8 @@
           <a:noFill/>
         </p:spPr>
         <p:txBody>
-          <a:bodyPr wrap="none" lIns="18288" rIns="18288" tIns="18288" bIns="18288" anchor="t">
-            <a:spAutoFit/>
+          <a:bodyPr wrap="square" lIns="18288" rIns="18288" tIns="18288" bIns="18288" anchor="t">
+            <a:normAutofit/>
           </a:bodyPr>
           <a:lstStyle/>
           <a:p>
@@ -14018,8 +14018,8 @@
           <a:noFill/>
         </p:spPr>
         <p:txBody>
-          <a:bodyPr wrap="none" lIns="18288" rIns="18288" tIns="18288" bIns="18288" anchor="t">
-            <a:spAutoFit/>
+          <a:bodyPr wrap="square" lIns="18288" rIns="18288" tIns="18288" bIns="18288" anchor="t">
+            <a:normAutofit/>
           </a:bodyPr>
           <a:lstStyle/>
           <a:p>
@@ -14096,8 +14096,8 @@
           <a:noFill/>
         </p:spPr>
         <p:txBody>
-          <a:bodyPr wrap="none" lIns="18288" rIns="18288" tIns="18288" bIns="18288" anchor="t">
-            <a:spAutoFit/>
+          <a:bodyPr wrap="square" lIns="18288" rIns="18288" tIns="18288" bIns="18288" anchor="t">
+            <a:normAutofit/>
           </a:bodyPr>
           <a:lstStyle/>
           <a:p>
@@ -14131,8 +14131,8 @@
           <a:noFill/>
         </p:spPr>
         <p:txBody>
-          <a:bodyPr wrap="none" lIns="18288" rIns="18288" tIns="18288" bIns="18288" anchor="t">
-            <a:spAutoFit/>
+          <a:bodyPr wrap="square" lIns="18288" rIns="18288" tIns="18288" bIns="18288" anchor="t">
+            <a:normAutofit/>
           </a:bodyPr>
           <a:lstStyle/>
           <a:p>
@@ -14166,8 +14166,8 @@
           <a:noFill/>
         </p:spPr>
         <p:txBody>
-          <a:bodyPr wrap="none" lIns="18288" rIns="18288" tIns="18288" bIns="18288" anchor="t">
-            <a:spAutoFit/>
+          <a:bodyPr wrap="square" lIns="18288" rIns="18288" tIns="18288" bIns="18288" anchor="t">
+            <a:normAutofit/>
           </a:bodyPr>
           <a:lstStyle/>
           <a:p>
@@ -14201,8 +14201,8 @@
           <a:noFill/>
         </p:spPr>
         <p:txBody>
-          <a:bodyPr wrap="none" lIns="18288" rIns="18288" tIns="18288" bIns="18288" anchor="t">
-            <a:spAutoFit/>
+          <a:bodyPr wrap="square" lIns="18288" rIns="18288" tIns="18288" bIns="18288" anchor="t">
+            <a:normAutofit/>
           </a:bodyPr>
           <a:lstStyle/>
           <a:p>
@@ -14279,8 +14279,8 @@
           <a:noFill/>
         </p:spPr>
         <p:txBody>
-          <a:bodyPr wrap="none" lIns="18288" rIns="18288" tIns="18288" bIns="18288" anchor="t">
-            <a:spAutoFit/>
+          <a:bodyPr wrap="square" lIns="18288" rIns="18288" tIns="18288" bIns="18288" anchor="t">
+            <a:normAutofit/>
           </a:bodyPr>
           <a:lstStyle/>
           <a:p>
@@ -14314,8 +14314,8 @@
           <a:noFill/>
         </p:spPr>
         <p:txBody>
-          <a:bodyPr wrap="none" lIns="18288" rIns="18288" tIns="18288" bIns="18288" anchor="t">
-            <a:spAutoFit/>
+          <a:bodyPr wrap="square" lIns="18288" rIns="18288" tIns="18288" bIns="18288" anchor="t">
+            <a:normAutofit/>
           </a:bodyPr>
           <a:lstStyle/>
           <a:p>
@@ -14349,8 +14349,8 @@
           <a:noFill/>
         </p:spPr>
         <p:txBody>
-          <a:bodyPr wrap="none" lIns="18288" rIns="18288" tIns="18288" bIns="18288" anchor="t">
-            <a:spAutoFit/>
+          <a:bodyPr wrap="square" lIns="18288" rIns="18288" tIns="18288" bIns="18288" anchor="t">
+            <a:normAutofit/>
           </a:bodyPr>
           <a:lstStyle/>
           <a:p>
@@ -14384,8 +14384,8 @@
           <a:noFill/>
         </p:spPr>
         <p:txBody>
-          <a:bodyPr wrap="none" lIns="18288" rIns="18288" tIns="18288" bIns="18288" anchor="t">
-            <a:spAutoFit/>
+          <a:bodyPr wrap="square" lIns="18288" rIns="18288" tIns="18288" bIns="18288" anchor="t">
+            <a:normAutofit/>
           </a:bodyPr>
           <a:lstStyle/>
           <a:p>
@@ -14419,8 +14419,8 @@
           <a:noFill/>
         </p:spPr>
         <p:txBody>
-          <a:bodyPr wrap="none" lIns="18288" rIns="18288" tIns="18288" bIns="18288" anchor="t">
-            <a:spAutoFit/>
+          <a:bodyPr wrap="square" lIns="18288" rIns="18288" tIns="18288" bIns="18288" anchor="t">
+            <a:normAutofit/>
           </a:bodyPr>
           <a:lstStyle/>
           <a:p>
@@ -14499,8 +14499,8 @@
           <a:noFill/>
         </p:spPr>
         <p:txBody>
-          <a:bodyPr wrap="none" lIns="18288" rIns="18288" tIns="18288" bIns="18288" anchor="t">
-            <a:spAutoFit/>
+          <a:bodyPr wrap="square" lIns="18288" rIns="18288" tIns="18288" bIns="18288" anchor="t">
+            <a:normAutofit/>
           </a:bodyPr>
           <a:lstStyle/>
           <a:p>
@@ -14534,8 +14534,8 @@
           <a:noFill/>
         </p:spPr>
         <p:txBody>
-          <a:bodyPr wrap="none" lIns="18288" rIns="18288" tIns="18288" bIns="18288" anchor="t">
-            <a:spAutoFit/>
+          <a:bodyPr wrap="square" lIns="18288" rIns="18288" tIns="18288" bIns="18288" anchor="t">
+            <a:normAutofit/>
           </a:bodyPr>
           <a:lstStyle/>
           <a:p>
@@ -14614,8 +14614,8 @@
           <a:noFill/>
         </p:spPr>
         <p:txBody>
-          <a:bodyPr wrap="none" lIns="18288" rIns="18288" tIns="18288" bIns="18288" anchor="t">
-            <a:spAutoFit/>
+          <a:bodyPr wrap="square" lIns="18288" rIns="18288" tIns="18288" bIns="18288" anchor="t">
+            <a:normAutofit/>
           </a:bodyPr>
           <a:lstStyle/>
           <a:p>
@@ -14649,8 +14649,8 @@
           <a:noFill/>
         </p:spPr>
         <p:txBody>
-          <a:bodyPr wrap="none" lIns="18288" rIns="18288" tIns="18288" bIns="18288" anchor="t">
-            <a:spAutoFit/>
+          <a:bodyPr wrap="square" lIns="18288" rIns="18288" tIns="18288" bIns="18288" anchor="t">
+            <a:normAutofit/>
           </a:bodyPr>
           <a:lstStyle/>
           <a:p>
@@ -14729,8 +14729,8 @@
           <a:noFill/>
         </p:spPr>
         <p:txBody>
-          <a:bodyPr wrap="none" lIns="18288" rIns="18288" tIns="18288" bIns="18288" anchor="t">
-            <a:spAutoFit/>
+          <a:bodyPr wrap="square" lIns="18288" rIns="18288" tIns="18288" bIns="18288" anchor="t">
+            <a:normAutofit/>
           </a:bodyPr>
           <a:lstStyle/>
           <a:p>
@@ -14764,8 +14764,8 @@
           <a:noFill/>
         </p:spPr>
         <p:txBody>
-          <a:bodyPr wrap="none" lIns="18288" rIns="18288" tIns="18288" bIns="18288" anchor="t">
-            <a:spAutoFit/>
+          <a:bodyPr wrap="square" lIns="18288" rIns="18288" tIns="18288" bIns="18288" anchor="t">
+            <a:normAutofit/>
           </a:bodyPr>
           <a:lstStyle/>
           <a:p>
@@ -14844,8 +14844,8 @@
           <a:noFill/>
         </p:spPr>
         <p:txBody>
-          <a:bodyPr wrap="none" lIns="18288" rIns="18288" tIns="18288" bIns="18288" anchor="t">
-            <a:spAutoFit/>
+          <a:bodyPr wrap="square" lIns="18288" rIns="18288" tIns="18288" bIns="18288" anchor="t">
+            <a:normAutofit/>
           </a:bodyPr>
           <a:lstStyle/>
           <a:p>
@@ -14879,8 +14879,8 @@
           <a:noFill/>
         </p:spPr>
         <p:txBody>
-          <a:bodyPr wrap="none" lIns="18288" rIns="18288" tIns="18288" bIns="18288" anchor="t">
-            <a:spAutoFit/>
+          <a:bodyPr wrap="square" lIns="18288" rIns="18288" tIns="18288" bIns="18288" anchor="t">
+            <a:normAutofit/>
           </a:bodyPr>
           <a:lstStyle/>
           <a:p>
@@ -14914,8 +14914,8 @@
           <a:noFill/>
         </p:spPr>
         <p:txBody>
-          <a:bodyPr wrap="none" lIns="18288" rIns="18288" tIns="18288" bIns="18288" anchor="t">
-            <a:spAutoFit/>
+          <a:bodyPr wrap="square" lIns="18288" rIns="18288" tIns="18288" bIns="18288" anchor="t">
+            <a:normAutofit/>
           </a:bodyPr>
           <a:lstStyle/>
           <a:p>
@@ -14949,8 +14949,8 @@
           <a:noFill/>
         </p:spPr>
         <p:txBody>
-          <a:bodyPr wrap="none" lIns="18288" rIns="18288" tIns="18288" bIns="18288" anchor="t">
-            <a:spAutoFit/>
+          <a:bodyPr wrap="square" lIns="18288" rIns="18288" tIns="18288" bIns="18288" anchor="t">
+            <a:normAutofit/>
           </a:bodyPr>
           <a:lstStyle/>
           <a:p>
@@ -14984,8 +14984,8 @@
           <a:noFill/>
         </p:spPr>
         <p:txBody>
-          <a:bodyPr wrap="none" lIns="18288" rIns="18288" tIns="18288" bIns="18288" anchor="t">
-            <a:spAutoFit/>
+          <a:bodyPr wrap="square" lIns="18288" rIns="18288" tIns="18288" bIns="18288" anchor="t">
+            <a:normAutofit/>
           </a:bodyPr>
           <a:lstStyle/>
           <a:p>
@@ -15045,8 +15045,8 @@
           <a:noFill/>
         </p:spPr>
         <p:txBody>
-          <a:bodyPr wrap="none" lIns="18288" rIns="18288" tIns="18288" bIns="18288" anchor="t">
-            <a:spAutoFit/>
+          <a:bodyPr wrap="square" lIns="18288" rIns="18288" tIns="18288" bIns="18288" anchor="t">
+            <a:normAutofit/>
           </a:bodyPr>
           <a:lstStyle/>
           <a:p>
@@ -15080,8 +15080,8 @@
           <a:noFill/>
         </p:spPr>
         <p:txBody>
-          <a:bodyPr wrap="none" lIns="18288" rIns="18288" tIns="18288" bIns="18288" anchor="t">
-            <a:spAutoFit/>
+          <a:bodyPr wrap="square" lIns="18288" rIns="18288" tIns="18288" bIns="18288" anchor="t">
+            <a:normAutofit/>
           </a:bodyPr>
           <a:lstStyle/>
           <a:p>
@@ -15158,8 +15158,8 @@
           <a:noFill/>
         </p:spPr>
         <p:txBody>
-          <a:bodyPr wrap="none" lIns="18288" rIns="18288" tIns="18288" bIns="18288" anchor="t">
-            <a:spAutoFit/>
+          <a:bodyPr wrap="square" lIns="18288" rIns="18288" tIns="18288" bIns="18288" anchor="t">
+            <a:normAutofit/>
           </a:bodyPr>
           <a:lstStyle/>
           <a:p>
@@ -15238,8 +15238,8 @@
           <a:noFill/>
         </p:spPr>
         <p:txBody>
-          <a:bodyPr wrap="none" lIns="18288" rIns="18288" tIns="18288" bIns="18288" anchor="t">
-            <a:spAutoFit/>
+          <a:bodyPr wrap="square" lIns="18288" rIns="18288" tIns="18288" bIns="18288" anchor="t">
+            <a:normAutofit/>
           </a:bodyPr>
           <a:lstStyle/>
           <a:p>
@@ -15273,8 +15273,8 @@
           <a:noFill/>
         </p:spPr>
         <p:txBody>
-          <a:bodyPr wrap="none" lIns="18288" rIns="18288" tIns="18288" bIns="18288" anchor="t">
-            <a:spAutoFit/>
+          <a:bodyPr wrap="square" lIns="18288" rIns="18288" tIns="18288" bIns="18288" anchor="t">
+            <a:normAutofit/>
           </a:bodyPr>
           <a:lstStyle/>
           <a:p>
@@ -15308,8 +15308,8 @@
           <a:noFill/>
         </p:spPr>
         <p:txBody>
-          <a:bodyPr wrap="none" lIns="18288" rIns="18288" tIns="18288" bIns="18288" anchor="t">
-            <a:spAutoFit/>
+          <a:bodyPr wrap="square" lIns="18288" rIns="18288" tIns="18288" bIns="18288" anchor="t">
+            <a:normAutofit/>
           </a:bodyPr>
           <a:lstStyle/>
           <a:p>
@@ -15388,8 +15388,8 @@
           <a:noFill/>
         </p:spPr>
         <p:txBody>
-          <a:bodyPr wrap="none" lIns="18288" rIns="18288" tIns="18288" bIns="18288" anchor="t">
-            <a:spAutoFit/>
+          <a:bodyPr wrap="square" lIns="18288" rIns="18288" tIns="18288" bIns="18288" anchor="t">
+            <a:normAutofit/>
           </a:bodyPr>
           <a:lstStyle/>
           <a:p>
@@ -15425,8 +15425,8 @@
           <a:noFill/>
         </p:spPr>
         <p:txBody>
-          <a:bodyPr wrap="none" lIns="18288" rIns="18288" tIns="18288" bIns="18288" anchor="t">
-            <a:spAutoFit/>
+          <a:bodyPr wrap="square" lIns="18288" rIns="18288" tIns="18288" bIns="18288" anchor="t">
+            <a:normAutofit/>
           </a:bodyPr>
           <a:lstStyle/>
           <a:p>
@@ -15460,8 +15460,8 @@
           <a:noFill/>
         </p:spPr>
         <p:txBody>
-          <a:bodyPr wrap="none" lIns="18288" rIns="18288" tIns="18288" bIns="18288" anchor="t">
-            <a:spAutoFit/>
+          <a:bodyPr wrap="square" lIns="18288" rIns="18288" tIns="18288" bIns="18288" anchor="t">
+            <a:normAutofit/>
           </a:bodyPr>
           <a:lstStyle/>
           <a:p>
@@ -15540,8 +15540,8 @@
           <a:noFill/>
         </p:spPr>
         <p:txBody>
-          <a:bodyPr wrap="none" lIns="18288" rIns="18288" tIns="18288" bIns="18288" anchor="t">
-            <a:spAutoFit/>
+          <a:bodyPr wrap="square" lIns="18288" rIns="18288" tIns="18288" bIns="18288" anchor="t">
+            <a:normAutofit/>
           </a:bodyPr>
           <a:lstStyle/>
           <a:p>
@@ -15577,8 +15577,8 @@
           <a:noFill/>
         </p:spPr>
         <p:txBody>
-          <a:bodyPr wrap="none" lIns="18288" rIns="18288" tIns="18288" bIns="18288" anchor="t">
-            <a:spAutoFit/>
+          <a:bodyPr wrap="square" lIns="18288" rIns="18288" tIns="18288" bIns="18288" anchor="t">
+            <a:normAutofit/>
           </a:bodyPr>
           <a:lstStyle/>
           <a:p>
@@ -15612,8 +15612,8 @@
           <a:noFill/>
         </p:spPr>
         <p:txBody>
-          <a:bodyPr wrap="none" lIns="18288" rIns="18288" tIns="18288" bIns="18288" anchor="t">
-            <a:spAutoFit/>
+          <a:bodyPr wrap="square" lIns="18288" rIns="18288" tIns="18288" bIns="18288" anchor="t">
+            <a:normAutofit/>
           </a:bodyPr>
           <a:lstStyle/>
           <a:p>
@@ -15647,8 +15647,8 @@
           <a:noFill/>
         </p:spPr>
         <p:txBody>
-          <a:bodyPr wrap="none" lIns="18288" rIns="18288" tIns="18288" bIns="18288" anchor="t">
-            <a:spAutoFit/>
+          <a:bodyPr wrap="square" lIns="18288" rIns="18288" tIns="18288" bIns="18288" anchor="t">
+            <a:normAutofit/>
           </a:bodyPr>
           <a:lstStyle/>
           <a:p>
@@ -15682,8 +15682,8 @@
           <a:noFill/>
         </p:spPr>
         <p:txBody>
-          <a:bodyPr wrap="none" lIns="18288" rIns="18288" tIns="18288" bIns="18288" anchor="t">
-            <a:spAutoFit/>
+          <a:bodyPr wrap="square" lIns="18288" rIns="18288" tIns="18288" bIns="18288" anchor="t">
+            <a:normAutofit/>
           </a:bodyPr>
           <a:lstStyle/>
           <a:p>
@@ -15717,8 +15717,8 @@
           <a:noFill/>
         </p:spPr>
         <p:txBody>
-          <a:bodyPr wrap="none" lIns="18288" rIns="18288" tIns="18288" bIns="18288" anchor="t">
-            <a:spAutoFit/>
+          <a:bodyPr wrap="square" lIns="18288" rIns="18288" tIns="18288" bIns="18288" anchor="t">
+            <a:normAutofit/>
           </a:bodyPr>
           <a:lstStyle/>
           <a:p>
@@ -15752,8 +15752,8 @@
           <a:noFill/>
         </p:spPr>
         <p:txBody>
-          <a:bodyPr wrap="none" lIns="18288" rIns="18288" tIns="18288" bIns="18288" anchor="t">
-            <a:spAutoFit/>
+          <a:bodyPr wrap="square" lIns="18288" rIns="18288" tIns="18288" bIns="18288" anchor="t">
+            <a:normAutofit/>
           </a:bodyPr>
           <a:lstStyle/>
           <a:p>

</xml_diff>